<commit_message>
Presentation: add sample code slide and GitHub link
</commit_message>
<xml_diff>
--- a/presentation/CAUSA_Final_Presentation.pptx
+++ b/presentation/CAUSA_Final_Presentation.pptx
@@ -25,9 +25,10 @@
     <p:sldId id="273" r:id="rId19"/>
     <p:sldId id="274" r:id="rId20"/>
     <p:sldId id="275" r:id="rId21"/>
+    <p:sldId id="276" r:id="rId22"/>
   </p:sldIdLst>
   <p:notesMasterIdLst>
-    <p:notesMasterId r:id="rId22"/>
+    <p:notesMasterId r:id="rId23"/>
   </p:notesMasterIdLst>
   <p:sldSz cx="12192000" cy="6858000"/>
   <p:notesSz cx="6858000" cy="12192000"/>
@@ -126,12 +127,12 @@
   <p:extLst>
     <p:ext uri="{521415D9-36F7-43E2-AB2F-B90AF26B5E84}">
       <p14:sectionLst xmlns:p14="http://schemas.microsoft.com/office/powerpoint/2010/main">
-        <p14:section name="Opening" id="{2420513c-2ef3-ef71-6168-fae26e7019d3}">
+        <p14:section name="Opening" id="{d76e2c81-4d64-6d72-e76d-f6412077c4a0}">
           <p14:sldIdLst>
             <p14:sldId id="256"/>
           </p14:sldIdLst>
         </p14:section>
-        <p14:section name="Problem and idea" id="{eaaaa10e-a8ee-2fac-8107-e3cb24d3ec1e}">
+        <p14:section name="Problem and idea" id="{dcdcdf44-ce2e-fbd6-9d92-61e056b7130a}">
           <p14:sldIdLst>
             <p14:sldId id="257"/>
             <p14:sldId id="258"/>
@@ -140,12 +141,12 @@
             <p14:sldId id="261"/>
           </p14:sldIdLst>
         </p14:section>
-        <p14:section name="Architecture" id="{030aad46-4ecd-bf36-0f5d-cfb778df81c8}">
+        <p14:section name="Architecture" id="{4f048547-59f9-4722-a12b-1db1ff4a00e4}">
           <p14:sldIdLst>
             <p14:sldId id="262"/>
           </p14:sldIdLst>
         </p14:section>
-        <p14:section name="Demonstration" id="{25013617-c486-b954-bf39-a096fb0afc27}">
+        <p14:section name="Demonstration" id="{3b014602-5b1f-e1fd-fc40-176d86fdd865}">
           <p14:sldIdLst>
             <p14:sldId id="263"/>
             <p14:sldId id="264"/>
@@ -154,24 +155,25 @@
             <p14:sldId id="267"/>
           </p14:sldIdLst>
         </p14:section>
-        <p14:section name="Internals and Studio" id="{075661e7-9ce7-b634-e69f-fa3f51cab449}">
+        <p14:section name="Internals and Studio" id="{54388091-785a-3582-f0ba-eceaeca10cb1}">
           <p14:sldIdLst>
             <p14:sldId id="268"/>
             <p14:sldId id="269"/>
             <p14:sldId id="270"/>
           </p14:sldIdLst>
         </p14:section>
-        <p14:section name="Evaluation" id="{40c417a4-a4dc-1b11-a5e2-782d53846d83}">
+        <p14:section name="Evaluation" id="{d3cb84cd-d013-e1c4-6fde-3a164a77a437}">
           <p14:sldIdLst>
             <p14:sldId id="271"/>
             <p14:sldId id="272"/>
           </p14:sldIdLst>
         </p14:section>
-        <p14:section name="Closing" id="{42e58714-4fd5-409d-e284-dedd8fc0b401}">
+        <p14:section name="Closing" id="{344d42fc-d4a9-927d-2ce6-c86aa786bbc6}">
           <p14:sldIdLst>
             <p14:sldId id="273"/>
             <p14:sldId id="274"/>
             <p14:sldId id="275"/>
+            <p14:sldId id="276"/>
           </p14:sldIdLst>
         </p14:section>
       </p14:sectionLst>
@@ -1789,8 +1791,7 @@
           <a:p>
             <a:r>
               <a:rPr lang="en-US" dirty="0"/>
-              <a:t>Close. CAUSA connects compilation with explainability and counterfactual reasoning: a small language and compiler in which dependencies are first-class, so a program can say why a value was produced, what depends on a binding, and what would happen under different inputs, all without disturbing the original execution. Three takeaways on the slide. The implementation is verified by an automated test suite and demonstrated by CAUSA Studio. The limitations are real and listed. Thank you; I am happy to take questions.
-Suggested backup answers: dependency direction (binding to names it uses, reverse derived); why C (native output, small testable runtime); why constant folding is safe (never folds anything that could raise a runtime error, and the dependency graph is re-verified); what is not claimed (no cross-platform validation, no performance superiority, no claim of being the first system of its kind).</a:t>
+              <a:t>An excerpt from causa/optimizer.py (code verbatim, comments shortened), the end of optimize(). After rewriting, the optimizer removes only constants that lost all users, re-validates the module (which re-derives the binding-level graph and compares it with the recorded provenance), and then checks that bindings, provenance, anchors and actions are untouched. A violation raises an internal compiler error rather than silently producing different output. This is the code behind the invariant on the Causal IR slide.</a:t>
             </a:r>
             <a:endParaRPr lang="en-US" dirty="0"/>
           </a:p>
@@ -1968,7 +1969,8 @@
           <a:p>
             <a:r>
               <a:rPr lang="en-US" dirty="0"/>
-              <a:t>Verification: each entry's title, authors, year and venue were checked against a publisher, library or official project page while building this deck. DOIs are given only where a page showed one. Items [1] and [5] show venue, volume and pages but no DOI, because none was confirmed. [7] has a stable official page but no DOI listed there. [8] is the CGO 2021 paper listed on Google Research's publication page; no DOI was confirmed. [10] is an arXiv preprint (not peer reviewed). A Halpern and Pearl structural-model causality paper was considered for the counterfactual theme and dropped because its journal venue could not be verified. Recent sources (2022 to 2024) are [6] (2022) and [10] (2023).</a:t>
+              <a:t>Close. CAUSA connects compilation with explainability and counterfactual reasoning: a small language and compiler in which dependencies are first-class, so a program can say why a value was produced, what depends on a binding, and what would happen under different inputs, all without disturbing the original execution. Three takeaways on the slide. The implementation is verified by an automated test suite and demonstrated by CAUSA Studio. The limitations are real and listed. Thank you; I am happy to take questions.
+Suggested backup answers: dependency direction (binding to names it uses, reverse derived); why C (native output, small testable runtime); why constant folding is safe (never folds anything that could raise a runtime error, and the dependency graph is re-verified); what is not claimed (no cross-platform validation, no performance superiority, no claim of being the first system of its kind).</a:t>
             </a:r>
             <a:endParaRPr lang="en-US" dirty="0"/>
           </a:p>
@@ -1992,6 +1994,94 @@
             <a:fld id="{F7021451-1387-4CA6-816F-3879F97B5CBC}" type="slidenum">
               <a:rPr lang="en-US"/>
               <a:t>20</a:t>
+            </a:fld>
+            <a:endParaRPr lang="en-US"/>
+          </a:p>
+        </p:txBody>
+      </p:sp>
+    </p:spTree>
+    <p:extLst>
+      <p:ext uri="{BB962C8B-B14F-4D97-AF65-F5344CB8AC3E}">
+        <p14:creationId xmlns:p14="http://schemas.microsoft.com/office/powerpoint/2010/main" val="1024086991"/>
+      </p:ext>
+    </p:extLst>
+  </p:cSld>
+  <p:clrMapOvr>
+    <a:masterClrMapping/>
+  </p:clrMapOvr>
+</p:notes>
+</file>
+
+<file path=ppt/notesSlides/notesSlide21.xml><?xml version="1.0" encoding="utf-8"?>
+<p:notes xmlns:a="http://schemas.openxmlformats.org/drawingml/2006/main" xmlns:r="http://schemas.openxmlformats.org/officeDocument/2006/relationships" xmlns:p="http://schemas.openxmlformats.org/presentationml/2006/main">
+  <p:cSld>
+    <p:spTree>
+      <p:nvGrpSpPr>
+        <p:cNvPr id="1" name=""/>
+        <p:cNvGrpSpPr/>
+        <p:nvPr/>
+      </p:nvGrpSpPr>
+      <p:grpSpPr>
+        <a:xfrm>
+          <a:off x="0" y="0"/>
+          <a:ext cx="0" cy="0"/>
+          <a:chOff x="0" y="0"/>
+          <a:chExt cx="0" cy="0"/>
+        </a:xfrm>
+      </p:grpSpPr>
+      <p:sp>
+        <p:nvSpPr>
+          <p:cNvPr id="2" name="Slide Image Placeholder 1"/>
+          <p:cNvSpPr>
+            <a:spLocks noGrp="1" noRot="1" noChangeAspect="1"/>
+          </p:cNvSpPr>
+          <p:nvPr>
+            <p:ph type="sldImg"/>
+          </p:nvPr>
+        </p:nvSpPr>
+        <p:spPr/>
+      </p:sp>
+      <p:sp>
+        <p:nvSpPr>
+          <p:cNvPr id="3" name="Notes Placeholder 2"/>
+          <p:cNvSpPr>
+            <a:spLocks noGrp="1"/>
+          </p:cNvSpPr>
+          <p:nvPr>
+            <p:ph type="body" idx="1"/>
+          </p:nvPr>
+        </p:nvSpPr>
+        <p:spPr/>
+        <p:txBody>
+          <a:bodyPr/>
+          <a:lstStyle/>
+          <a:p>
+            <a:r>
+              <a:rPr lang="en-US" dirty="0"/>
+              <a:t>Verification: each entry's title, authors, year and venue were checked against a publisher, library or official project page while building this deck. DOIs are given only where a page showed one. Items [1] and [5] show venue, volume and pages but no DOI, because none was confirmed. [7] has a stable official page but no DOI listed there. [8] is the CGO 2021 paper listed on Google Research's publication page; no DOI was confirmed. [10] is an arXiv preprint (not peer reviewed). A Halpern and Pearl structural-model causality paper was considered for the counterfactual theme and dropped because its journal venue could not be verified. Recent sources (2022 to 2024) are [6] (2022) and [10] (2023).</a:t>
+            </a:r>
+            <a:endParaRPr lang="en-US" dirty="0"/>
+          </a:p>
+        </p:txBody>
+      </p:sp>
+      <p:sp>
+        <p:nvSpPr>
+          <p:cNvPr id="4" name="Slide Number Placeholder 3"/>
+          <p:cNvSpPr>
+            <a:spLocks noGrp="1"/>
+          </p:cNvSpPr>
+          <p:nvPr>
+            <p:ph type="sldNum" sz="quarter" idx="10"/>
+          </p:nvPr>
+        </p:nvSpPr>
+        <p:spPr/>
+        <p:txBody>
+          <a:bodyPr/>
+          <a:lstStyle/>
+          <a:p>
+            <a:fld id="{F7021451-1387-4CA6-816F-3879F97B5CBC}" type="slidenum">
+              <a:rPr lang="en-US"/>
+              <a:t>21</a:t>
             </a:fld>
             <a:endParaRPr lang="en-US"/>
           </a:p>
@@ -15644,14 +15734,16 @@
       </p:grpSpPr>
       <p:sp>
         <p:nvSpPr>
-          <p:cNvPr id="3" name="text-501"/>
-          <p:cNvSpPr txBox="1"/>
-          <p:nvPr/>
-        </p:nvSpPr>
-        <p:spPr>
-          <a:xfrm>
-            <a:off x="731520" y="822960"/>
-            <a:ext cx="10515600" cy="1463040"/>
+          <p:cNvPr id="2" name="Text 0"/>
+          <p:cNvSpPr/>
+          <p:nvPr>
+            <p:ph idx="100" type="title" hasCustomPrompt="1"/>
+          </p:nvPr>
+        </p:nvSpPr>
+        <p:spPr>
+          <a:xfrm>
+            <a:off x="548640" y="365760"/>
+            <a:ext cx="11091672" cy="685800"/>
           </a:xfrm>
           <a:prstGeom prst="rect">
             <a:avLst/>
@@ -15663,11 +15755,11 @@
           <a:bodyPr wrap="square" lIns="0" tIns="0" rIns="0" bIns="0" rtlCol="0" anchor="t"/>
           <a:lstStyle/>
           <a:p>
-            <a:pPr indent="0" marL="0">
-              <a:buNone/>
-            </a:pPr>
-            <a:r>
-              <a:rPr lang="en-US" sz="3800" b="1" dirty="0">
+            <a:pPr algn="l" indent="0" marL="0">
+              <a:buNone/>
+            </a:pPr>
+            <a:r>
+              <a:rPr lang="en-US" sz="2800" b="1" spc="-50" kern="0" dirty="0">
                 <a:solidFill>
                   <a:srgbClr val="ECECEE"/>
                 </a:solidFill>
@@ -15675,26 +15767,393 @@
                 <a:ea typeface="Inter" pitchFamily="34" charset="-122"/>
                 <a:cs typeface="Inter" pitchFamily="34" charset="-120"/>
               </a:rPr>
-              <a:t>CAUSA connects compilation with explainability and counterfactual reasoning.</a:t>
-            </a:r>
-            <a:endParaRPr lang="en-US" sz="3800" dirty="0"/>
-          </a:p>
-        </p:txBody>
-      </p:sp>
-      <p:sp>
-        <p:nvSpPr>
-          <p:cNvPr id="4" name="card-502"/>
+              <a:t>Sample code: the optimizer's safety check</a:t>
+            </a:r>
+            <a:endParaRPr lang="en-US" sz="2800" dirty="0"/>
+          </a:p>
+        </p:txBody>
+      </p:sp>
+      <p:sp>
+        <p:nvSpPr>
+          <p:cNvPr id="3" name="text-501"/>
+          <p:cNvSpPr txBox="1"/>
+          <p:nvPr/>
+        </p:nvSpPr>
+        <p:spPr>
+          <a:xfrm>
+            <a:off x="548640" y="6446520"/>
+            <a:ext cx="5486400" cy="274320"/>
+          </a:xfrm>
+          <a:prstGeom prst="rect">
+            <a:avLst/>
+          </a:prstGeom>
+          <a:noFill/>
+          <a:ln/>
+        </p:spPr>
+        <p:txBody>
+          <a:bodyPr wrap="square" lIns="0" tIns="0" rIns="0" bIns="0" rtlCol="0" anchor="t"/>
+          <a:lstStyle/>
+          <a:p>
+            <a:pPr indent="0" marL="0">
+              <a:buNone/>
+            </a:pPr>
+            <a:r>
+              <a:rPr lang="en-US" sz="1000" dirty="0">
+                <a:solidFill>
+                  <a:srgbClr val="7C7C84"/>
+                </a:solidFill>
+                <a:latin typeface="Inter" pitchFamily="34" charset="0"/>
+                <a:ea typeface="Inter" pitchFamily="34" charset="-122"/>
+                <a:cs typeface="Inter" pitchFamily="34" charset="-120"/>
+              </a:rPr>
+              <a:t>CAUSA   Closing</a:t>
+            </a:r>
+            <a:endParaRPr lang="en-US" sz="1000" dirty="0"/>
+          </a:p>
+        </p:txBody>
+      </p:sp>
+      <p:sp>
+        <p:nvSpPr>
+          <p:cNvPr id="5" name="panel-502"/>
           <p:cNvSpPr/>
           <p:nvPr/>
         </p:nvSpPr>
         <p:spPr>
           <a:xfrm>
-            <a:off x="731520" y="2651760"/>
-            <a:ext cx="3474720" cy="2103120"/>
+            <a:off x="548640" y="1234440"/>
+            <a:ext cx="7406640" cy="4114800"/>
           </a:xfrm>
           <a:prstGeom prst="roundRect">
             <a:avLst>
-              <a:gd name="adj" fmla="val 3478"/>
+              <a:gd name="adj" fmla="val 1778"/>
+            </a:avLst>
+          </a:prstGeom>
+          <a:solidFill>
+            <a:srgbClr val="121214"/>
+          </a:solidFill>
+          <a:ln w="12700">
+            <a:solidFill>
+              <a:srgbClr val="121214"/>
+            </a:solidFill>
+            <a:prstDash val="solid"/>
+          </a:ln>
+        </p:spPr>
+      </p:sp>
+      <p:sp>
+        <p:nvSpPr>
+          <p:cNvPr id="6" name="text-503"/>
+          <p:cNvSpPr txBox="1"/>
+          <p:nvPr/>
+        </p:nvSpPr>
+        <p:spPr>
+          <a:xfrm>
+            <a:off x="777240" y="1371600"/>
+            <a:ext cx="6949440" cy="274320"/>
+          </a:xfrm>
+          <a:prstGeom prst="rect">
+            <a:avLst/>
+          </a:prstGeom>
+          <a:noFill/>
+          <a:ln/>
+        </p:spPr>
+        <p:txBody>
+          <a:bodyPr wrap="square" lIns="0" tIns="0" rIns="0" bIns="0" rtlCol="0" anchor="t"/>
+          <a:lstStyle/>
+          <a:p>
+            <a:pPr indent="0" marL="0">
+              <a:buNone/>
+            </a:pPr>
+            <a:r>
+              <a:rPr lang="en-US" sz="1100" b="1" spc="100" kern="0" dirty="0">
+                <a:solidFill>
+                  <a:srgbClr val="8E8E96"/>
+                </a:solidFill>
+                <a:latin typeface="Inter" pitchFamily="34" charset="0"/>
+                <a:ea typeface="Inter" pitchFamily="34" charset="-122"/>
+                <a:cs typeface="Inter" pitchFamily="34" charset="-120"/>
+              </a:rPr>
+              <a:t>causa/optimizer.py  (excerpt of optimize; comments shortened)</a:t>
+            </a:r>
+            <a:endParaRPr lang="en-US" sz="1100" dirty="0"/>
+          </a:p>
+        </p:txBody>
+      </p:sp>
+      <p:sp>
+        <p:nvSpPr>
+          <p:cNvPr id="7" name="text-504"/>
+          <p:cNvSpPr txBox="1"/>
+          <p:nvPr/>
+        </p:nvSpPr>
+        <p:spPr>
+          <a:xfrm>
+            <a:off x="777240" y="1691640"/>
+            <a:ext cx="6949440" cy="3520440"/>
+          </a:xfrm>
+          <a:prstGeom prst="rect">
+            <a:avLst/>
+          </a:prstGeom>
+          <a:noFill/>
+          <a:ln/>
+        </p:spPr>
+        <p:txBody>
+          <a:bodyPr wrap="square" lIns="0" tIns="0" rIns="0" bIns="0" rtlCol="0" anchor="t"/>
+          <a:lstStyle/>
+          <a:p>
+            <a:pPr indent="0" marL="0">
+              <a:spcAft>
+                <a:spcPts val="200"/>
+              </a:spcAft>
+              <a:buNone/>
+            </a:pPr>
+            <a:r>
+              <a:rPr lang="en-US" sz="1050" dirty="0">
+                <a:solidFill>
+                  <a:srgbClr val="8E8E96"/>
+                </a:solidFill>
+                <a:latin typeface="Consolas" pitchFamily="34" charset="0"/>
+                <a:ea typeface="Consolas" pitchFamily="34" charset="-122"/>
+                <a:cs typeface="Consolas" pitchFamily="34" charset="-120"/>
+              </a:rPr>
+              <a:t>    # Remove consts that lost all users.</a:t>
+            </a:r>
+            <a:endParaRPr lang="en-US" sz="1600" dirty="0"/>
+          </a:p>
+          <a:p>
+            <a:pPr indent="0" marL="0">
+              <a:spcAft>
+                <a:spcPts val="200"/>
+              </a:spcAft>
+              <a:buNone/>
+            </a:pPr>
+            <a:r>
+              <a:rPr lang="en-US" sz="1050" dirty="0">
+                <a:solidFill>
+                  <a:srgbClr val="ECECEE"/>
+                </a:solidFill>
+                <a:latin typeface="Consolas" pitchFamily="34" charset="0"/>
+                <a:ea typeface="Consolas" pitchFamily="34" charset="-122"/>
+                <a:cs typeface="Consolas" pitchFamily="34" charset="-120"/>
+              </a:rPr>
+              <a:t>    used = {o for n in nodes.values() for o in n.operands}</a:t>
+            </a:r>
+            <a:endParaRPr lang="en-US" sz="1600" dirty="0"/>
+          </a:p>
+          <a:p>
+            <a:pPr indent="0" marL="0">
+              <a:spcAft>
+                <a:spcPts val="200"/>
+              </a:spcAft>
+              <a:buNone/>
+            </a:pPr>
+            <a:r>
+              <a:rPr lang="en-US" sz="1050" dirty="0">
+                <a:solidFill>
+                  <a:srgbClr val="ECECEE"/>
+                </a:solidFill>
+                <a:latin typeface="Consolas" pitchFamily="34" charset="0"/>
+                <a:ea typeface="Consolas" pitchFamily="34" charset="-122"/>
+                <a:cs typeface="Consolas" pitchFamily="34" charset="-120"/>
+              </a:rPr>
+              <a:t>    used |= {s.root for s in steps if isinstance(s, Assert)}</a:t>
+            </a:r>
+            <a:endParaRPr lang="en-US" sz="1600" dirty="0"/>
+          </a:p>
+          <a:p>
+            <a:pPr indent="0" marL="0">
+              <a:spcAft>
+                <a:spcPts val="200"/>
+              </a:spcAft>
+              <a:buNone/>
+            </a:pPr>
+            <a:r>
+              <a:rPr lang="en-US" sz="1050" dirty="0">
+                <a:solidFill>
+                  <a:srgbClr val="A78BFA"/>
+                </a:solidFill>
+                <a:latin typeface="Consolas" pitchFamily="34" charset="0"/>
+                <a:ea typeface="Consolas" pitchFamily="34" charset="-122"/>
+                <a:cs typeface="Consolas" pitchFamily="34" charset="-120"/>
+              </a:rPr>
+              <a:t>    for node_id in sorted(nodes):</a:t>
+            </a:r>
+            <a:endParaRPr lang="en-US" sz="1600" dirty="0"/>
+          </a:p>
+          <a:p>
+            <a:pPr indent="0" marL="0">
+              <a:spcAft>
+                <a:spcPts val="200"/>
+              </a:spcAft>
+              <a:buNone/>
+            </a:pPr>
+            <a:r>
+              <a:rPr lang="en-US" sz="1050" dirty="0">
+                <a:solidFill>
+                  <a:srgbClr val="ECECEE"/>
+                </a:solidFill>
+                <a:latin typeface="Consolas" pitchFamily="34" charset="0"/>
+                <a:ea typeface="Consolas" pitchFamily="34" charset="-122"/>
+                <a:cs typeface="Consolas" pitchFamily="34" charset="-120"/>
+              </a:rPr>
+              <a:t>        if nodes[node_id].kind is NodeKind.CONST and node_id not in used:</a:t>
+            </a:r>
+            <a:endParaRPr lang="en-US" sz="1600" dirty="0"/>
+          </a:p>
+          <a:p>
+            <a:pPr indent="0" marL="0">
+              <a:spcAft>
+                <a:spcPts val="200"/>
+              </a:spcAft>
+              <a:buNone/>
+            </a:pPr>
+            <a:r>
+              <a:rPr lang="en-US" sz="1050" dirty="0">
+                <a:solidFill>
+                  <a:srgbClr val="ECECEE"/>
+                </a:solidFill>
+                <a:latin typeface="Consolas" pitchFamily="34" charset="0"/>
+                <a:ea typeface="Consolas" pitchFamily="34" charset="-122"/>
+                <a:cs typeface="Consolas" pitchFamily="34" charset="-120"/>
+              </a:rPr>
+              <a:t>            del nodes[node_id]</a:t>
+            </a:r>
+            <a:endParaRPr lang="en-US" sz="1600" dirty="0"/>
+          </a:p>
+          <a:p>
+            <a:pPr indent="0" marL="0">
+              <a:spcAft>
+                <a:spcPts val="200"/>
+              </a:spcAft>
+              <a:buNone/>
+            </a:pPr>
+            <a:r>
+              <a:rPr lang="en-US" sz="1050" dirty="0">
+                <a:solidFill>
+                  <a:srgbClr val="FB923C"/>
+                </a:solidFill>
+                <a:latin typeface="Consolas" pitchFamily="34" charset="0"/>
+                <a:ea typeface="Consolas" pitchFamily="34" charset="-122"/>
+                <a:cs typeface="Consolas" pitchFamily="34" charset="-120"/>
+              </a:rPr>
+              <a:t>            log.append(Rewrite("remove", node_id, "const node", "no remaining users"))</a:t>
+            </a:r>
+            <a:endParaRPr lang="en-US" sz="1600" dirty="0"/>
+          </a:p>
+          <a:p>
+            <a:pPr indent="0" marL="0">
+              <a:spcAft>
+                <a:spcPts val="200"/>
+              </a:spcAft>
+              <a:buNone/>
+            </a:pPr>
+            <a:r>
+              <a:rPr lang="en-US" sz="1050" dirty="0">
+                <a:solidFill>
+                  <a:srgbClr val="ECECEE"/>
+                </a:solidFill>
+                <a:latin typeface="Consolas" pitchFamily="34" charset="0"/>
+                <a:ea typeface="Consolas" pitchFamily="34" charset="-122"/>
+                <a:cs typeface="Consolas" pitchFamily="34" charset="-120"/>
+              </a:rPr>
+              <a:t> </a:t>
+            </a:r>
+            <a:endParaRPr lang="en-US" sz="1600" dirty="0"/>
+          </a:p>
+          <a:p>
+            <a:pPr indent="0" marL="0">
+              <a:spcAft>
+                <a:spcPts val="200"/>
+              </a:spcAft>
+              <a:buNone/>
+            </a:pPr>
+            <a:r>
+              <a:rPr lang="en-US" sz="1050" dirty="0">
+                <a:solidFill>
+                  <a:srgbClr val="ECECEE"/>
+                </a:solidFill>
+                <a:latin typeface="Consolas" pitchFamily="34" charset="0"/>
+                <a:ea typeface="Consolas" pitchFamily="34" charset="-122"/>
+                <a:cs typeface="Consolas" pitchFamily="34" charset="-120"/>
+              </a:rPr>
+              <a:t>    result = replace(module, nodes=tuple(nodes.values()), steps=tuple(steps))</a:t>
+            </a:r>
+            <a:endParaRPr lang="en-US" sz="1600" dirty="0"/>
+          </a:p>
+          <a:p>
+            <a:pPr indent="0" marL="0">
+              <a:spcAft>
+                <a:spcPts val="200"/>
+              </a:spcAft>
+              <a:buNone/>
+            </a:pPr>
+            <a:r>
+              <a:rPr lang="en-US" sz="1050" dirty="0">
+                <a:solidFill>
+                  <a:srgbClr val="86EFAC"/>
+                </a:solidFill>
+                <a:latin typeface="Consolas" pitchFamily="34" charset="0"/>
+                <a:ea typeface="Consolas" pitchFamily="34" charset="-122"/>
+                <a:cs typeface="Consolas" pitchFamily="34" charset="-120"/>
+              </a:rPr>
+              <a:t>    validate_ir(result)  # re-derives the binding-level graph, compares with provenance</a:t>
+            </a:r>
+            <a:endParaRPr lang="en-US" sz="1600" dirty="0"/>
+          </a:p>
+          <a:p>
+            <a:pPr indent="0" marL="0">
+              <a:spcAft>
+                <a:spcPts val="200"/>
+              </a:spcAft>
+              <a:buNone/>
+            </a:pPr>
+            <a:r>
+              <a:rPr lang="en-US" sz="1050" dirty="0">
+                <a:solidFill>
+                  <a:srgbClr val="86EFAC"/>
+                </a:solidFill>
+                <a:latin typeface="Consolas" pitchFamily="34" charset="0"/>
+                <a:ea typeface="Consolas" pitchFamily="34" charset="-122"/>
+                <a:cs typeface="Consolas" pitchFamily="34" charset="-120"/>
+              </a:rPr>
+              <a:t>    _check_preserved(module, result)</a:t>
+            </a:r>
+            <a:endParaRPr lang="en-US" sz="1600" dirty="0"/>
+          </a:p>
+          <a:p>
+            <a:pPr indent="0" marL="0">
+              <a:spcAft>
+                <a:spcPts val="200"/>
+              </a:spcAft>
+              <a:buNone/>
+            </a:pPr>
+            <a:r>
+              <a:rPr lang="en-US" sz="1050" dirty="0">
+                <a:solidFill>
+                  <a:srgbClr val="ECECEE"/>
+                </a:solidFill>
+                <a:latin typeface="Consolas" pitchFamily="34" charset="0"/>
+                <a:ea typeface="Consolas" pitchFamily="34" charset="-122"/>
+                <a:cs typeface="Consolas" pitchFamily="34" charset="-120"/>
+              </a:rPr>
+              <a:t>    return OptimizationResult(result, tuple(log))</a:t>
+            </a:r>
+            <a:endParaRPr lang="en-US" sz="1600" dirty="0"/>
+          </a:p>
+        </p:txBody>
+      </p:sp>
+      <p:sp>
+        <p:nvSpPr>
+          <p:cNvPr id="8" name="card-505"/>
+          <p:cNvSpPr/>
+          <p:nvPr/>
+        </p:nvSpPr>
+        <p:spPr>
+          <a:xfrm>
+            <a:off x="8229600" y="1234440"/>
+            <a:ext cx="3410712" cy="1234440"/>
+          </a:xfrm>
+          <a:prstGeom prst="roundRect">
+            <a:avLst>
+              <a:gd name="adj" fmla="val 5926"/>
             </a:avLst>
           </a:prstGeom>
           <a:solidFill>
@@ -15710,14 +16169,14 @@
       </p:sp>
       <p:sp>
         <p:nvSpPr>
-          <p:cNvPr id="5" name="text-503"/>
-          <p:cNvSpPr txBox="1"/>
-          <p:nvPr/>
-        </p:nvSpPr>
-        <p:spPr>
-          <a:xfrm>
-            <a:off x="960120" y="2788920"/>
-            <a:ext cx="3017520" cy="365760"/>
+          <p:cNvPr id="9" name="text-506"/>
+          <p:cNvSpPr txBox="1"/>
+          <p:nvPr/>
+        </p:nvSpPr>
+        <p:spPr>
+          <a:xfrm>
+            <a:off x="8412480" y="1371600"/>
+            <a:ext cx="3108960" cy="274320"/>
           </a:xfrm>
           <a:prstGeom prst="rect">
             <a:avLst/>
@@ -15733,46 +16192,7 @@
               <a:buNone/>
             </a:pPr>
             <a:r>
-              <a:rPr lang="en-US" sz="1600" b="1" dirty="0">
-                <a:solidFill>
-                  <a:srgbClr val="7C7C84"/>
-                </a:solidFill>
-                <a:latin typeface="Consolas" pitchFamily="34" charset="0"/>
-                <a:ea typeface="Consolas" pitchFamily="34" charset="-122"/>
-                <a:cs typeface="Consolas" pitchFamily="34" charset="-120"/>
-              </a:rPr>
-              <a:t>explain</a:t>
-            </a:r>
-            <a:endParaRPr lang="en-US" sz="1600" dirty="0"/>
-          </a:p>
-        </p:txBody>
-      </p:sp>
-      <p:sp>
-        <p:nvSpPr>
-          <p:cNvPr id="6" name="text-504"/>
-          <p:cNvSpPr txBox="1"/>
-          <p:nvPr/>
-        </p:nvSpPr>
-        <p:spPr>
-          <a:xfrm>
-            <a:off x="960120" y="3200400"/>
-            <a:ext cx="3017520" cy="457200"/>
-          </a:xfrm>
-          <a:prstGeom prst="rect">
-            <a:avLst/>
-          </a:prstGeom>
-          <a:noFill/>
-          <a:ln/>
-        </p:spPr>
-        <p:txBody>
-          <a:bodyPr wrap="square" lIns="0" tIns="0" rIns="0" bIns="0" rtlCol="0" anchor="t"/>
-          <a:lstStyle/>
-          <a:p>
-            <a:pPr indent="0" marL="0">
-              <a:buNone/>
-            </a:pPr>
-            <a:r>
-              <a:rPr lang="en-US" sz="2400" b="1" dirty="0">
+              <a:rPr lang="en-US" sz="1400" b="1" dirty="0">
                 <a:solidFill>
                   <a:srgbClr val="22D3EE"/>
                 </a:solidFill>
@@ -15780,22 +16200,22 @@
                 <a:ea typeface="Inter" pitchFamily="34" charset="-122"/>
                 <a:cs typeface="Inter" pitchFamily="34" charset="-120"/>
               </a:rPr>
-              <a:t>Understand</a:t>
-            </a:r>
-            <a:endParaRPr lang="en-US" sz="2400" dirty="0"/>
-          </a:p>
-        </p:txBody>
-      </p:sp>
-      <p:sp>
-        <p:nvSpPr>
-          <p:cNvPr id="7" name="text-505"/>
-          <p:cNvSpPr txBox="1"/>
-          <p:nvPr/>
-        </p:nvSpPr>
-        <p:spPr>
-          <a:xfrm>
-            <a:off x="960120" y="3703320"/>
-            <a:ext cx="3017520" cy="914400"/>
+              <a:t>Only constants are removed</a:t>
+            </a:r>
+            <a:endParaRPr lang="en-US" sz="1400" dirty="0"/>
+          </a:p>
+        </p:txBody>
+      </p:sp>
+      <p:sp>
+        <p:nvSpPr>
+          <p:cNvPr id="10" name="text-507"/>
+          <p:cNvSpPr txBox="1"/>
+          <p:nvPr/>
+        </p:nvSpPr>
+        <p:spPr>
+          <a:xfrm>
+            <a:off x="8412480" y="1737360"/>
+            <a:ext cx="3108960" cy="640080"/>
           </a:xfrm>
           <a:prstGeom prst="rect">
             <a:avLst/>
@@ -15811,34 +16231,34 @@
               <a:buNone/>
             </a:pPr>
             <a:r>
-              <a:rPr lang="en-US" sz="1600" dirty="0">
-                <a:solidFill>
-                  <a:srgbClr val="ECECEE"/>
+              <a:rPr lang="en-US" sz="1200" dirty="0">
+                <a:solidFill>
+                  <a:srgbClr val="8E8E96"/>
                 </a:solidFill>
                 <a:latin typeface="Inter" pitchFamily="34" charset="0"/>
                 <a:ea typeface="Inter" pitchFamily="34" charset="-122"/>
                 <a:cs typeface="Inter" pitchFamily="34" charset="-120"/>
               </a:rPr>
-              <a:t>why a value was produced</a:t>
-            </a:r>
-            <a:endParaRPr lang="en-US" sz="1600" dirty="0"/>
-          </a:p>
-        </p:txBody>
-      </p:sp>
-      <p:sp>
-        <p:nvSpPr>
-          <p:cNvPr id="8" name="card-506"/>
+              <a:t>A constant cannot raise a runtime error, so deleting unused ones is safe.</a:t>
+            </a:r>
+            <a:endParaRPr lang="en-US" sz="1200" dirty="0"/>
+          </a:p>
+        </p:txBody>
+      </p:sp>
+      <p:sp>
+        <p:nvSpPr>
+          <p:cNvPr id="11" name="card-508"/>
           <p:cNvSpPr/>
           <p:nvPr/>
         </p:nvSpPr>
         <p:spPr>
           <a:xfrm>
-            <a:off x="4389120" y="2651760"/>
-            <a:ext cx="3474720" cy="2103120"/>
+            <a:off x="8229600" y="2651760"/>
+            <a:ext cx="3410712" cy="1234440"/>
           </a:xfrm>
           <a:prstGeom prst="roundRect">
             <a:avLst>
-              <a:gd name="adj" fmla="val 3478"/>
+              <a:gd name="adj" fmla="val 5926"/>
             </a:avLst>
           </a:prstGeom>
           <a:solidFill>
@@ -15854,14 +16274,14 @@
       </p:sp>
       <p:sp>
         <p:nvSpPr>
-          <p:cNvPr id="9" name="text-507"/>
-          <p:cNvSpPr txBox="1"/>
-          <p:nvPr/>
-        </p:nvSpPr>
-        <p:spPr>
-          <a:xfrm>
-            <a:off x="4617720" y="2788920"/>
-            <a:ext cx="3017520" cy="365760"/>
+          <p:cNvPr id="12" name="text-509"/>
+          <p:cNvSpPr txBox="1"/>
+          <p:nvPr/>
+        </p:nvSpPr>
+        <p:spPr>
+          <a:xfrm>
+            <a:off x="8412480" y="2788920"/>
+            <a:ext cx="3108960" cy="274320"/>
           </a:xfrm>
           <a:prstGeom prst="rect">
             <a:avLst/>
@@ -15877,69 +16297,30 @@
               <a:buNone/>
             </a:pPr>
             <a:r>
-              <a:rPr lang="en-US" sz="1600" b="1" dirty="0">
-                <a:solidFill>
-                  <a:srgbClr val="7C7C84"/>
-                </a:solidFill>
-                <a:latin typeface="Consolas" pitchFamily="34" charset="0"/>
-                <a:ea typeface="Consolas" pitchFamily="34" charset="-122"/>
-                <a:cs typeface="Consolas" pitchFamily="34" charset="-120"/>
-              </a:rPr>
-              <a:t>impact</a:t>
-            </a:r>
-            <a:endParaRPr lang="en-US" sz="1600" dirty="0"/>
-          </a:p>
-        </p:txBody>
-      </p:sp>
-      <p:sp>
-        <p:nvSpPr>
-          <p:cNvPr id="10" name="text-508"/>
-          <p:cNvSpPr txBox="1"/>
-          <p:nvPr/>
-        </p:nvSpPr>
-        <p:spPr>
-          <a:xfrm>
-            <a:off x="4617720" y="3200400"/>
-            <a:ext cx="3017520" cy="457200"/>
-          </a:xfrm>
-          <a:prstGeom prst="rect">
-            <a:avLst/>
-          </a:prstGeom>
-          <a:noFill/>
-          <a:ln/>
-        </p:spPr>
-        <p:txBody>
-          <a:bodyPr wrap="square" lIns="0" tIns="0" rIns="0" bIns="0" rtlCol="0" anchor="t"/>
-          <a:lstStyle/>
-          <a:p>
-            <a:pPr indent="0" marL="0">
-              <a:buNone/>
-            </a:pPr>
-            <a:r>
-              <a:rPr lang="en-US" sz="2400" b="1" dirty="0">
-                <a:solidFill>
-                  <a:srgbClr val="22D3EE"/>
+              <a:rPr lang="en-US" sz="1400" b="1" dirty="0">
+                <a:solidFill>
+                  <a:srgbClr val="86EFAC"/>
                 </a:solidFill>
                 <a:latin typeface="Inter" pitchFamily="34" charset="0"/>
                 <a:ea typeface="Inter" pitchFamily="34" charset="-122"/>
                 <a:cs typeface="Inter" pitchFamily="34" charset="-120"/>
               </a:rPr>
-              <a:t>Trace</a:t>
-            </a:r>
-            <a:endParaRPr lang="en-US" sz="2400" dirty="0"/>
-          </a:p>
-        </p:txBody>
-      </p:sp>
-      <p:sp>
-        <p:nvSpPr>
-          <p:cNvPr id="11" name="text-509"/>
-          <p:cNvSpPr txBox="1"/>
-          <p:nvPr/>
-        </p:nvSpPr>
-        <p:spPr>
-          <a:xfrm>
-            <a:off x="4617720" y="3703320"/>
-            <a:ext cx="3017520" cy="914400"/>
+              <a:t>Re-derive and compare</a:t>
+            </a:r>
+            <a:endParaRPr lang="en-US" sz="1400" dirty="0"/>
+          </a:p>
+        </p:txBody>
+      </p:sp>
+      <p:sp>
+        <p:nvSpPr>
+          <p:cNvPr id="13" name="text-510"/>
+          <p:cNvSpPr txBox="1"/>
+          <p:nvPr/>
+        </p:nvSpPr>
+        <p:spPr>
+          <a:xfrm>
+            <a:off x="8412480" y="3154680"/>
+            <a:ext cx="3108960" cy="685800"/>
           </a:xfrm>
           <a:prstGeom prst="rect">
             <a:avLst/>
@@ -15955,34 +16336,34 @@
               <a:buNone/>
             </a:pPr>
             <a:r>
-              <a:rPr lang="en-US" sz="1600" dirty="0">
-                <a:solidFill>
-                  <a:srgbClr val="ECECEE"/>
+              <a:rPr lang="en-US" sz="1200" dirty="0">
+                <a:solidFill>
+                  <a:srgbClr val="8E8E96"/>
                 </a:solidFill>
                 <a:latin typeface="Inter" pitchFamily="34" charset="0"/>
                 <a:ea typeface="Inter" pitchFamily="34" charset="-122"/>
                 <a:cs typeface="Inter" pitchFamily="34" charset="-120"/>
               </a:rPr>
-              <a:t>the impact of a binding</a:t>
-            </a:r>
-            <a:endParaRPr lang="en-US" sz="1600" dirty="0"/>
-          </a:p>
-        </p:txBody>
-      </p:sp>
-      <p:sp>
-        <p:nvSpPr>
-          <p:cNvPr id="12" name="card-510"/>
+              <a:t>validate_ir rebuilds the dependency graph and checks it against provenance.</a:t>
+            </a:r>
+            <a:endParaRPr lang="en-US" sz="1200" dirty="0"/>
+          </a:p>
+        </p:txBody>
+      </p:sp>
+      <p:sp>
+        <p:nvSpPr>
+          <p:cNvPr id="14" name="card-511"/>
           <p:cNvSpPr/>
           <p:nvPr/>
         </p:nvSpPr>
         <p:spPr>
           <a:xfrm>
-            <a:off x="8046720" y="2651760"/>
-            <a:ext cx="3474720" cy="2103120"/>
+            <a:off x="8229600" y="4069080"/>
+            <a:ext cx="3410712" cy="1280160"/>
           </a:xfrm>
           <a:prstGeom prst="roundRect">
             <a:avLst>
-              <a:gd name="adj" fmla="val 3478"/>
+              <a:gd name="adj" fmla="val 5714"/>
             </a:avLst>
           </a:prstGeom>
           <a:solidFill>
@@ -15998,14 +16379,14 @@
       </p:sp>
       <p:sp>
         <p:nvSpPr>
-          <p:cNvPr id="13" name="text-511"/>
-          <p:cNvSpPr txBox="1"/>
-          <p:nvPr/>
-        </p:nvSpPr>
-        <p:spPr>
-          <a:xfrm>
-            <a:off x="8275320" y="2788920"/>
-            <a:ext cx="3017520" cy="365760"/>
+          <p:cNvPr id="15" name="text-512"/>
+          <p:cNvSpPr txBox="1"/>
+          <p:nvPr/>
+        </p:nvSpPr>
+        <p:spPr>
+          <a:xfrm>
+            <a:off x="8412480" y="4206240"/>
+            <a:ext cx="3108960" cy="274320"/>
           </a:xfrm>
           <a:prstGeom prst="rect">
             <a:avLst/>
@@ -16021,69 +16402,30 @@
               <a:buNone/>
             </a:pPr>
             <a:r>
-              <a:rPr lang="en-US" sz="1600" b="1" dirty="0">
-                <a:solidFill>
-                  <a:srgbClr val="7C7C84"/>
-                </a:solidFill>
-                <a:latin typeface="Consolas" pitchFamily="34" charset="0"/>
-                <a:ea typeface="Consolas" pitchFamily="34" charset="-122"/>
-                <a:cs typeface="Consolas" pitchFamily="34" charset="-120"/>
-              </a:rPr>
-              <a:t>whatif</a:t>
-            </a:r>
-            <a:endParaRPr lang="en-US" sz="1600" dirty="0"/>
-          </a:p>
-        </p:txBody>
-      </p:sp>
-      <p:sp>
-        <p:nvSpPr>
-          <p:cNvPr id="14" name="text-512"/>
-          <p:cNvSpPr txBox="1"/>
-          <p:nvPr/>
-        </p:nvSpPr>
-        <p:spPr>
-          <a:xfrm>
-            <a:off x="8275320" y="3200400"/>
-            <a:ext cx="3017520" cy="457200"/>
-          </a:xfrm>
-          <a:prstGeom prst="rect">
-            <a:avLst/>
-          </a:prstGeom>
-          <a:noFill/>
-          <a:ln/>
-        </p:spPr>
-        <p:txBody>
-          <a:bodyPr wrap="square" lIns="0" tIns="0" rIns="0" bIns="0" rtlCol="0" anchor="t"/>
-          <a:lstStyle/>
-          <a:p>
-            <a:pPr indent="0" marL="0">
-              <a:buNone/>
-            </a:pPr>
-            <a:r>
-              <a:rPr lang="en-US" sz="2400" b="1" dirty="0">
-                <a:solidFill>
-                  <a:srgbClr val="22D3EE"/>
+              <a:rPr lang="en-US" sz="1400" b="1" dirty="0">
+                <a:solidFill>
+                  <a:srgbClr val="FB923C"/>
                 </a:solidFill>
                 <a:latin typeface="Inter" pitchFamily="34" charset="0"/>
                 <a:ea typeface="Inter" pitchFamily="34" charset="-122"/>
                 <a:cs typeface="Inter" pitchFamily="34" charset="-120"/>
               </a:rPr>
-              <a:t>Explore</a:t>
-            </a:r>
-            <a:endParaRPr lang="en-US" sz="2400" dirty="0"/>
-          </a:p>
-        </p:txBody>
-      </p:sp>
-      <p:sp>
-        <p:nvSpPr>
-          <p:cNvPr id="15" name="text-513"/>
-          <p:cNvSpPr txBox="1"/>
-          <p:nvPr/>
-        </p:nvSpPr>
-        <p:spPr>
-          <a:xfrm>
-            <a:off x="8275320" y="3703320"/>
-            <a:ext cx="3017520" cy="914400"/>
+              <a:t>Fail loudly</a:t>
+            </a:r>
+            <a:endParaRPr lang="en-US" sz="1400" dirty="0"/>
+          </a:p>
+        </p:txBody>
+      </p:sp>
+      <p:sp>
+        <p:nvSpPr>
+          <p:cNvPr id="16" name="text-513"/>
+          <p:cNvSpPr txBox="1"/>
+          <p:nvPr/>
+        </p:nvSpPr>
+        <p:spPr>
+          <a:xfrm>
+            <a:off x="8412480" y="4572000"/>
+            <a:ext cx="3108960" cy="685800"/>
           </a:xfrm>
           <a:prstGeom prst="rect">
             <a:avLst/>
@@ -16099,195 +16441,54 @@
               <a:buNone/>
             </a:pPr>
             <a:r>
-              <a:rPr lang="en-US" sz="1600" dirty="0">
-                <a:solidFill>
-                  <a:srgbClr val="ECECEE"/>
+              <a:rPr lang="en-US" sz="1200" dirty="0">
+                <a:solidFill>
+                  <a:srgbClr val="8E8E96"/>
                 </a:solidFill>
                 <a:latin typeface="Inter" pitchFamily="34" charset="0"/>
                 <a:ea typeface="Inter" pitchFamily="34" charset="-122"/>
                 <a:cs typeface="Inter" pitchFamily="34" charset="-120"/>
               </a:rPr>
-              <a:t>alternative inputs without changing the original execution</a:t>
-            </a:r>
-            <a:endParaRPr lang="en-US" sz="1600" dirty="0"/>
-          </a:p>
-        </p:txBody>
-      </p:sp>
-      <p:sp>
-        <p:nvSpPr>
-          <p:cNvPr id="16" name="text-514"/>
-          <p:cNvSpPr txBox="1"/>
-          <p:nvPr/>
-        </p:nvSpPr>
-        <p:spPr>
-          <a:xfrm>
-            <a:off x="731520" y="5257800"/>
-            <a:ext cx="5486400" cy="914400"/>
-          </a:xfrm>
-          <a:prstGeom prst="rect">
-            <a:avLst/>
-          </a:prstGeom>
-          <a:noFill/>
-          <a:ln/>
-        </p:spPr>
-        <p:txBody>
-          <a:bodyPr wrap="square" lIns="0" tIns="0" rIns="0" bIns="0" rtlCol="0" anchor="ctr"/>
-          <a:lstStyle/>
-          <a:p>
-            <a:pPr indent="0" marL="0">
-              <a:buNone/>
-            </a:pPr>
-            <a:r>
-              <a:rPr lang="en-US" sz="4800" b="1" dirty="0">
-                <a:solidFill>
-                  <a:srgbClr val="ECECEE"/>
+              <a:t>Any change to a binding, anchor or action raises an internal compiler error.</a:t>
+            </a:r>
+            <a:endParaRPr lang="en-US" sz="1200" dirty="0"/>
+          </a:p>
+        </p:txBody>
+      </p:sp>
+      <p:sp>
+        <p:nvSpPr>
+          <p:cNvPr id="17" name="text-514"/>
+          <p:cNvSpPr txBox="1"/>
+          <p:nvPr/>
+        </p:nvSpPr>
+        <p:spPr>
+          <a:xfrm>
+            <a:off x="548640" y="5623560"/>
+            <a:ext cx="7315200" cy="365760"/>
+          </a:xfrm>
+          <a:prstGeom prst="rect">
+            <a:avLst/>
+          </a:prstGeom>
+          <a:noFill/>
+          <a:ln/>
+        </p:spPr>
+        <p:txBody>
+          <a:bodyPr wrap="square" lIns="0" tIns="0" rIns="0" bIns="0" rtlCol="0" anchor="t"/>
+          <a:lstStyle/>
+          <a:p>
+            <a:pPr indent="0" marL="0">
+              <a:buNone/>
+            </a:pPr>
+            <a:r>
+              <a:rPr lang="en-US" sz="1400" dirty="0">
+                <a:solidFill>
+                  <a:srgbClr val="8E8E96"/>
                 </a:solidFill>
                 <a:latin typeface="Inter" pitchFamily="34" charset="0"/>
                 <a:ea typeface="Inter" pitchFamily="34" charset="-122"/>
                 <a:cs typeface="Inter" pitchFamily="34" charset="-120"/>
               </a:rPr>
-              <a:t>Questions?</a:t>
-            </a:r>
-            <a:endParaRPr lang="en-US" sz="4800" dirty="0"/>
-          </a:p>
-        </p:txBody>
-      </p:sp>
-      <p:sp>
-        <p:nvSpPr>
-          <p:cNvPr id="17" name="panel-515"/>
-          <p:cNvSpPr/>
-          <p:nvPr/>
-        </p:nvSpPr>
-        <p:spPr>
-          <a:xfrm>
-            <a:off x="7589520" y="4983480"/>
-            <a:ext cx="4050792" cy="1417320"/>
-          </a:xfrm>
-          <a:prstGeom prst="roundRect">
-            <a:avLst>
-              <a:gd name="adj" fmla="val 5161"/>
-            </a:avLst>
-          </a:prstGeom>
-          <a:solidFill>
-            <a:srgbClr val="121214"/>
-          </a:solidFill>
-          <a:ln w="12700">
-            <a:solidFill>
-              <a:srgbClr val="121214"/>
-            </a:solidFill>
-            <a:prstDash val="solid"/>
-          </a:ln>
-        </p:spPr>
-      </p:sp>
-      <p:sp>
-        <p:nvSpPr>
-          <p:cNvPr id="18" name="arrow-516"/>
-          <p:cNvSpPr/>
-          <p:nvPr/>
-        </p:nvSpPr>
-        <p:spPr>
-          <a:xfrm flipV="1">
-            <a:off x="8869680" y="5532120"/>
-            <a:ext cx="274320" cy="228600"/>
-          </a:xfrm>
-          <a:prstGeom prst="line">
-            <a:avLst/>
-          </a:prstGeom>
-          <a:noFill/>
-          <a:ln w="19050">
-            <a:solidFill>
-              <a:srgbClr val="8E8E96"/>
-            </a:solidFill>
-            <a:prstDash val="solid"/>
-            <a:tailEnd type="triangle"/>
-          </a:ln>
-        </p:spPr>
-      </p:sp>
-      <p:sp>
-        <p:nvSpPr>
-          <p:cNvPr id="19" name="arrow-517"/>
-          <p:cNvSpPr/>
-          <p:nvPr/>
-        </p:nvSpPr>
-        <p:spPr>
-          <a:xfrm>
-            <a:off x="10241280" y="5532120"/>
-            <a:ext cx="182880" cy="228600"/>
-          </a:xfrm>
-          <a:prstGeom prst="line">
-            <a:avLst/>
-          </a:prstGeom>
-          <a:noFill/>
-          <a:ln w="19050">
-            <a:solidFill>
-              <a:srgbClr val="8E8E96"/>
-            </a:solidFill>
-            <a:prstDash val="solid"/>
-            <a:tailEnd type="triangle"/>
-          </a:ln>
-        </p:spPr>
-      </p:sp>
-      <p:sp>
-        <p:nvSpPr>
-          <p:cNvPr id="20" name="node-518"/>
-          <p:cNvSpPr/>
-          <p:nvPr/>
-        </p:nvSpPr>
-        <p:spPr>
-          <a:xfrm>
-            <a:off x="7772400" y="5486400"/>
-            <a:ext cx="1097280" cy="548640"/>
-          </a:xfrm>
-          <a:prstGeom prst="roundRect">
-            <a:avLst>
-              <a:gd name="adj" fmla="val 10000"/>
-            </a:avLst>
-          </a:prstGeom>
-          <a:solidFill>
-            <a:srgbClr val="1C1C21"/>
-          </a:solidFill>
-          <a:ln w="19050">
-            <a:solidFill>
-              <a:srgbClr val="86EFAC"/>
-            </a:solidFill>
-            <a:prstDash val="solid"/>
-          </a:ln>
-        </p:spPr>
-      </p:sp>
-      <p:sp>
-        <p:nvSpPr>
-          <p:cNvPr id="21" name="text-519"/>
-          <p:cNvSpPr txBox="1"/>
-          <p:nvPr/>
-        </p:nvSpPr>
-        <p:spPr>
-          <a:xfrm>
-            <a:off x="7772400" y="5486400"/>
-            <a:ext cx="1097280" cy="548640"/>
-          </a:xfrm>
-          <a:prstGeom prst="rect">
-            <a:avLst/>
-          </a:prstGeom>
-          <a:noFill/>
-          <a:ln/>
-        </p:spPr>
-        <p:txBody>
-          <a:bodyPr wrap="square" lIns="0" tIns="0" rIns="0" bIns="0" rtlCol="0" anchor="ctr"/>
-          <a:lstStyle/>
-          <a:p>
-            <a:pPr algn="ctr" indent="0" marL="0">
-              <a:buNone/>
-            </a:pPr>
-            <a:r>
-              <a:rPr lang="en-US" sz="1400" b="1" dirty="0">
-                <a:solidFill>
-                  <a:srgbClr val="ECECEE"/>
-                </a:solidFill>
-                <a:latin typeface="Consolas" pitchFamily="34" charset="0"/>
-                <a:ea typeface="Consolas" pitchFamily="34" charset="-122"/>
-                <a:cs typeface="Consolas" pitchFamily="34" charset="-120"/>
-              </a:rPr>
-              <a:t>price</a:t>
+              <a:t>Full source: github.com/ujvall/causa</a:t>
             </a:r>
             <a:endParaRPr lang="en-US" sz="1400" dirty="0"/>
           </a:p>
@@ -16295,133 +16496,49 @@
       </p:sp>
       <p:sp>
         <p:nvSpPr>
-          <p:cNvPr id="22" name="node-520"/>
-          <p:cNvSpPr/>
-          <p:nvPr/>
-        </p:nvSpPr>
-        <p:spPr>
-          <a:xfrm>
-            <a:off x="9144000" y="5257800"/>
-            <a:ext cx="1097280" cy="548640"/>
-          </a:xfrm>
-          <a:prstGeom prst="roundRect">
-            <a:avLst>
-              <a:gd name="adj" fmla="val 10000"/>
-            </a:avLst>
-          </a:prstGeom>
-          <a:solidFill>
-            <a:srgbClr val="1C1C21"/>
-          </a:solidFill>
-          <a:ln w="19050">
-            <a:solidFill>
-              <a:srgbClr val="60A5FA"/>
-            </a:solidFill>
-            <a:prstDash val="solid"/>
-          </a:ln>
-        </p:spPr>
-      </p:sp>
-      <p:sp>
-        <p:nvSpPr>
-          <p:cNvPr id="23" name="text-521"/>
-          <p:cNvSpPr txBox="1"/>
-          <p:nvPr/>
-        </p:nvSpPr>
-        <p:spPr>
-          <a:xfrm>
-            <a:off x="9144000" y="5257800"/>
-            <a:ext cx="1097280" cy="548640"/>
-          </a:xfrm>
-          <a:prstGeom prst="rect">
-            <a:avLst/>
-          </a:prstGeom>
-          <a:noFill/>
-          <a:ln/>
-        </p:spPr>
-        <p:txBody>
-          <a:bodyPr wrap="square" lIns="0" tIns="0" rIns="0" bIns="0" rtlCol="0" anchor="ctr"/>
-          <a:lstStyle/>
-          <a:p>
-            <a:pPr algn="ctr" indent="0" marL="0">
-              <a:buNone/>
-            </a:pPr>
-            <a:r>
-              <a:rPr lang="en-US" sz="1400" b="1" dirty="0">
-                <a:solidFill>
-                  <a:srgbClr val="ECECEE"/>
-                </a:solidFill>
-                <a:latin typeface="Consolas" pitchFamily="34" charset="0"/>
-                <a:ea typeface="Consolas" pitchFamily="34" charset="-122"/>
-                <a:cs typeface="Consolas" pitchFamily="34" charset="-120"/>
-              </a:rPr>
-              <a:t>savings</a:t>
-            </a:r>
-            <a:endParaRPr lang="en-US" sz="1400" dirty="0"/>
-          </a:p>
-        </p:txBody>
-      </p:sp>
-      <p:sp>
-        <p:nvSpPr>
-          <p:cNvPr id="24" name="node-522"/>
-          <p:cNvSpPr/>
-          <p:nvPr/>
-        </p:nvSpPr>
-        <p:spPr>
-          <a:xfrm>
-            <a:off x="10424160" y="5486400"/>
-            <a:ext cx="1097280" cy="548640"/>
-          </a:xfrm>
-          <a:prstGeom prst="roundRect">
-            <a:avLst>
-              <a:gd name="adj" fmla="val 10000"/>
-            </a:avLst>
-          </a:prstGeom>
-          <a:solidFill>
-            <a:srgbClr val="1C1C21"/>
-          </a:solidFill>
-          <a:ln w="19050">
-            <a:solidFill>
-              <a:srgbClr val="22D3EE"/>
-            </a:solidFill>
-            <a:prstDash val="solid"/>
-          </a:ln>
-        </p:spPr>
-      </p:sp>
-      <p:sp>
-        <p:nvSpPr>
-          <p:cNvPr id="25" name="text-523"/>
-          <p:cNvSpPr txBox="1"/>
-          <p:nvPr/>
-        </p:nvSpPr>
-        <p:spPr>
-          <a:xfrm>
-            <a:off x="10424160" y="5486400"/>
-            <a:ext cx="1097280" cy="548640"/>
-          </a:xfrm>
-          <a:prstGeom prst="rect">
-            <a:avLst/>
-          </a:prstGeom>
-          <a:noFill/>
-          <a:ln/>
-        </p:spPr>
-        <p:txBody>
-          <a:bodyPr wrap="square" lIns="0" tIns="0" rIns="0" bIns="0" rtlCol="0" anchor="ctr"/>
-          <a:lstStyle/>
-          <a:p>
-            <a:pPr algn="ctr" indent="0" marL="0">
-              <a:buNone/>
-            </a:pPr>
-            <a:r>
-              <a:rPr lang="en-US" sz="1400" b="1" dirty="0">
-                <a:solidFill>
-                  <a:srgbClr val="ECECEE"/>
-                </a:solidFill>
-                <a:latin typeface="Consolas" pitchFamily="34" charset="0"/>
-                <a:ea typeface="Consolas" pitchFamily="34" charset="-122"/>
-                <a:cs typeface="Consolas" pitchFamily="34" charset="-120"/>
-              </a:rPr>
-              <a:t>total</a:t>
-            </a:r>
-            <a:endParaRPr lang="en-US" sz="1400" dirty="0"/>
+          <p:cNvPr id="25" name="Slide Number Placeholder 0"/>
+          <p:cNvSpPr>
+            <a:spLocks noGrp="1"/>
+          </p:cNvSpPr>
+          <p:nvPr>
+            <p:ph type="sldNum" sz="quarter" idx="4294967295"/>
+          </p:nvPr>
+        </p:nvSpPr>
+        <p:spPr>
+          <a:xfrm>
+            <a:off x="11091672" y="6446520"/>
+            <a:ext cx="548640" cy="274320"/>
+          </a:xfrm>
+          <a:prstGeom prst="rect">
+            <a:avLst/>
+          </a:prstGeom>
+          <a:extLst>
+            <a:ext uri="{C572A759-6A51-4108-AA02-DFA0A04FC94B}">
+              <ma14:wrappingTextBoxFlag xmlns:ma14="http://schemas.microsoft.com/office/mac/drawingml/2011/main" val="0"/>
+            </a:ext>
+          </a:extLst>
+        </p:spPr>
+        <p:txBody>
+          <a:bodyPr/>
+          <a:lstStyle>
+            <a:lvl1pPr>
+              <a:defRPr sz="1000">
+                <a:solidFill>
+                  <a:srgbClr val="7C7C84"/>
+                </a:solidFill>
+                <a:latin typeface="Inter"/>
+                <a:ea typeface="Inter"/>
+                <a:cs typeface="Inter"/>
+              </a:defRPr>
+            </a:lvl1pPr>
+          </a:lstStyle>
+          <a:p>
+            <a:pPr algn="r"/>
+            <a:fld id="{F7021451-1387-4CA6-816F-3879F97B5CBC}" type="slidenum">
+              <a:rPr b="0" lang="en-US"/>
+              <a:t>19</a:t>
+            </a:fld>
+            <a:endParaRPr lang="en-US"/>
           </a:p>
         </p:txBody>
       </p:sp>
@@ -17289,16 +17406,14 @@
       </p:grpSpPr>
       <p:sp>
         <p:nvSpPr>
-          <p:cNvPr id="2" name="Text 0"/>
-          <p:cNvSpPr/>
-          <p:nvPr>
-            <p:ph idx="100" type="title" hasCustomPrompt="1"/>
-          </p:nvPr>
-        </p:nvSpPr>
-        <p:spPr>
-          <a:xfrm>
-            <a:off x="548640" y="365760"/>
-            <a:ext cx="11091672" cy="685800"/>
+          <p:cNvPr id="3" name="text-515"/>
+          <p:cNvSpPr txBox="1"/>
+          <p:nvPr/>
+        </p:nvSpPr>
+        <p:spPr>
+          <a:xfrm>
+            <a:off x="731520" y="822960"/>
+            <a:ext cx="10515600" cy="1463040"/>
           </a:xfrm>
           <a:prstGeom prst="rect">
             <a:avLst/>
@@ -17310,11 +17425,11 @@
           <a:bodyPr wrap="square" lIns="0" tIns="0" rIns="0" bIns="0" rtlCol="0" anchor="t"/>
           <a:lstStyle/>
           <a:p>
-            <a:pPr algn="l" indent="0" marL="0">
-              <a:buNone/>
-            </a:pPr>
-            <a:r>
-              <a:rPr lang="en-US" sz="2800" b="1" spc="-50" kern="0" dirty="0">
+            <a:pPr indent="0" marL="0">
+              <a:buNone/>
+            </a:pPr>
+            <a:r>
+              <a:rPr lang="en-US" sz="3800" b="1" dirty="0">
                 <a:solidFill>
                   <a:srgbClr val="ECECEE"/>
                 </a:solidFill>
@@ -17322,65 +17437,26 @@
                 <a:ea typeface="Inter" pitchFamily="34" charset="-122"/>
                 <a:cs typeface="Inter" pitchFamily="34" charset="-120"/>
               </a:rPr>
-              <a:t>Appendix: references</a:t>
-            </a:r>
-            <a:endParaRPr lang="en-US" sz="2800" dirty="0"/>
-          </a:p>
-        </p:txBody>
-      </p:sp>
-      <p:sp>
-        <p:nvSpPr>
-          <p:cNvPr id="3" name="text-524"/>
-          <p:cNvSpPr txBox="1"/>
-          <p:nvPr/>
-        </p:nvSpPr>
-        <p:spPr>
-          <a:xfrm>
-            <a:off x="548640" y="6446520"/>
-            <a:ext cx="5486400" cy="274320"/>
-          </a:xfrm>
-          <a:prstGeom prst="rect">
-            <a:avLst/>
-          </a:prstGeom>
-          <a:noFill/>
-          <a:ln/>
-        </p:spPr>
-        <p:txBody>
-          <a:bodyPr wrap="square" lIns="0" tIns="0" rIns="0" bIns="0" rtlCol="0" anchor="t"/>
-          <a:lstStyle/>
-          <a:p>
-            <a:pPr indent="0" marL="0">
-              <a:buNone/>
-            </a:pPr>
-            <a:r>
-              <a:rPr lang="en-US" sz="1000" dirty="0">
-                <a:solidFill>
-                  <a:srgbClr val="7C7C84"/>
-                </a:solidFill>
-                <a:latin typeface="Inter" pitchFamily="34" charset="0"/>
-                <a:ea typeface="Inter" pitchFamily="34" charset="-122"/>
-                <a:cs typeface="Inter" pitchFamily="34" charset="-120"/>
-              </a:rPr>
-              <a:t>CAUSA   Closing</a:t>
-            </a:r>
-            <a:endParaRPr lang="en-US" sz="1000" dirty="0"/>
-          </a:p>
-        </p:txBody>
-      </p:sp>
-      <p:sp>
-        <p:nvSpPr>
-          <p:cNvPr id="5" name="card-525"/>
+              <a:t>CAUSA connects compilation with explainability and counterfactual reasoning.</a:t>
+            </a:r>
+            <a:endParaRPr lang="en-US" sz="3800" dirty="0"/>
+          </a:p>
+        </p:txBody>
+      </p:sp>
+      <p:sp>
+        <p:nvSpPr>
+          <p:cNvPr id="4" name="card-516"/>
           <p:cNvSpPr/>
           <p:nvPr/>
         </p:nvSpPr>
         <p:spPr>
           <a:xfrm>
-            <a:off x="548640" y="1280160"/>
-            <a:ext cx="5440680" cy="4892040"/>
+            <a:off x="731520" y="2651760"/>
+            <a:ext cx="3474720" cy="2103120"/>
           </a:xfrm>
           <a:prstGeom prst="roundRect">
             <a:avLst>
-              <a:gd name="adj" fmla="val 1495"/>
+              <a:gd name="adj" fmla="val 3478"/>
             </a:avLst>
           </a:prstGeom>
           <a:solidFill>
@@ -17396,14 +17472,14 @@
       </p:sp>
       <p:sp>
         <p:nvSpPr>
-          <p:cNvPr id="6" name="text-526"/>
-          <p:cNvSpPr txBox="1"/>
-          <p:nvPr/>
-        </p:nvSpPr>
-        <p:spPr>
-          <a:xfrm>
-            <a:off x="731520" y="1417320"/>
-            <a:ext cx="5120640" cy="4663440"/>
+          <p:cNvPr id="5" name="text-517"/>
+          <p:cNvSpPr txBox="1"/>
+          <p:nvPr/>
+        </p:nvSpPr>
+        <p:spPr>
+          <a:xfrm>
+            <a:off x="960120" y="2788920"/>
+            <a:ext cx="3017520" cy="365760"/>
           </a:xfrm>
           <a:prstGeom prst="rect">
             <a:avLst/>
@@ -17416,33 +17492,88 @@
           <a:lstStyle/>
           <a:p>
             <a:pPr indent="0" marL="0">
-              <a:spcAft>
-                <a:spcPts val="900"/>
-              </a:spcAft>
-              <a:buNone/>
-            </a:pPr>
-            <a:r>
-              <a:rPr lang="en-US" sz="1300" dirty="0">
-                <a:solidFill>
-                  <a:srgbClr val="ECECEE"/>
+              <a:buNone/>
+            </a:pPr>
+            <a:r>
+              <a:rPr lang="en-US" sz="1600" b="1" dirty="0">
+                <a:solidFill>
+                  <a:srgbClr val="7C7C84"/>
+                </a:solidFill>
+                <a:latin typeface="Consolas" pitchFamily="34" charset="0"/>
+                <a:ea typeface="Consolas" pitchFamily="34" charset="-122"/>
+                <a:cs typeface="Consolas" pitchFamily="34" charset="-120"/>
+              </a:rPr>
+              <a:t>explain</a:t>
+            </a:r>
+            <a:endParaRPr lang="en-US" sz="1600" dirty="0"/>
+          </a:p>
+        </p:txBody>
+      </p:sp>
+      <p:sp>
+        <p:nvSpPr>
+          <p:cNvPr id="6" name="text-518"/>
+          <p:cNvSpPr txBox="1"/>
+          <p:nvPr/>
+        </p:nvSpPr>
+        <p:spPr>
+          <a:xfrm>
+            <a:off x="960120" y="3200400"/>
+            <a:ext cx="3017520" cy="457200"/>
+          </a:xfrm>
+          <a:prstGeom prst="rect">
+            <a:avLst/>
+          </a:prstGeom>
+          <a:noFill/>
+          <a:ln/>
+        </p:spPr>
+        <p:txBody>
+          <a:bodyPr wrap="square" lIns="0" tIns="0" rIns="0" bIns="0" rtlCol="0" anchor="t"/>
+          <a:lstStyle/>
+          <a:p>
+            <a:pPr indent="0" marL="0">
+              <a:buNone/>
+            </a:pPr>
+            <a:r>
+              <a:rPr lang="en-US" sz="2400" b="1" dirty="0">
+                <a:solidFill>
+                  <a:srgbClr val="22D3EE"/>
                 </a:solidFill>
                 <a:latin typeface="Inter" pitchFamily="34" charset="0"/>
                 <a:ea typeface="Inter" pitchFamily="34" charset="-122"/>
                 <a:cs typeface="Inter" pitchFamily="34" charset="-120"/>
               </a:rPr>
-              <a:t>[1] M. Weiser, “Program Slicing,” IEEE Transactions on Software Engineering, vol. 10, no. 4, pp. 352–357, 1984.</a:t>
-            </a:r>
-            <a:endParaRPr lang="en-US" sz="1600" dirty="0"/>
-          </a:p>
-          <a:p>
-            <a:pPr indent="0" marL="0">
-              <a:spcAft>
-                <a:spcPts val="900"/>
-              </a:spcAft>
-              <a:buNone/>
-            </a:pPr>
-            <a:r>
-              <a:rPr lang="en-US" sz="1300" dirty="0">
+              <a:t>Understand</a:t>
+            </a:r>
+            <a:endParaRPr lang="en-US" sz="2400" dirty="0"/>
+          </a:p>
+        </p:txBody>
+      </p:sp>
+      <p:sp>
+        <p:nvSpPr>
+          <p:cNvPr id="7" name="text-519"/>
+          <p:cNvSpPr txBox="1"/>
+          <p:nvPr/>
+        </p:nvSpPr>
+        <p:spPr>
+          <a:xfrm>
+            <a:off x="960120" y="3703320"/>
+            <a:ext cx="3017520" cy="914400"/>
+          </a:xfrm>
+          <a:prstGeom prst="rect">
+            <a:avLst/>
+          </a:prstGeom>
+          <a:noFill/>
+          <a:ln/>
+        </p:spPr>
+        <p:txBody>
+          <a:bodyPr wrap="square" lIns="0" tIns="0" rIns="0" bIns="0" rtlCol="0" anchor="t"/>
+          <a:lstStyle/>
+          <a:p>
+            <a:pPr indent="0" marL="0">
+              <a:buNone/>
+            </a:pPr>
+            <a:r>
+              <a:rPr lang="en-US" sz="1600" dirty="0">
                 <a:solidFill>
                   <a:srgbClr val="ECECEE"/>
                 </a:solidFill>
@@ -17450,86 +17581,26 @@
                 <a:ea typeface="Inter" pitchFamily="34" charset="-122"/>
                 <a:cs typeface="Inter" pitchFamily="34" charset="-120"/>
               </a:rPr>
-              <a:t>[2] J. Ferrante, K. J. Ottenstein, J. D. Warren, “The Program Dependence Graph and Its Use in Optimization,” ACM TOPLAS, vol. 9, no. 3, pp. 319–349, 1987. doi:10.1145/24039.24041</a:t>
+              <a:t>why a value was produced</a:t>
             </a:r>
             <a:endParaRPr lang="en-US" sz="1600" dirty="0"/>
           </a:p>
-          <a:p>
-            <a:pPr indent="0" marL="0">
-              <a:spcAft>
-                <a:spcPts val="900"/>
-              </a:spcAft>
-              <a:buNone/>
-            </a:pPr>
-            <a:r>
-              <a:rPr lang="en-US" sz="1300" dirty="0">
-                <a:solidFill>
-                  <a:srgbClr val="ECECEE"/>
-                </a:solidFill>
-                <a:latin typeface="Inter" pitchFamily="34" charset="0"/>
-                <a:ea typeface="Inter" pitchFamily="34" charset="-122"/>
-                <a:cs typeface="Inter" pitchFamily="34" charset="-120"/>
-              </a:rPr>
-              <a:t>[3] J. Cheney, L. Chiticariu, W.-C. Tan, “Provenance in Databases: Why, How, and Where,” Foundations and Trends in Databases, vol. 1, no. 4, pp. 379–474, 2009. doi:10.1561/1900000006</a:t>
-            </a:r>
-            <a:endParaRPr lang="en-US" sz="1600" dirty="0"/>
-          </a:p>
-          <a:p>
-            <a:pPr indent="0" marL="0">
-              <a:spcAft>
-                <a:spcPts val="900"/>
-              </a:spcAft>
-              <a:buNone/>
-            </a:pPr>
-            <a:r>
-              <a:rPr lang="en-US" sz="1300" dirty="0">
-                <a:solidFill>
-                  <a:srgbClr val="ECECEE"/>
-                </a:solidFill>
-                <a:latin typeface="Inter" pitchFamily="34" charset="0"/>
-                <a:ea typeface="Inter" pitchFamily="34" charset="-122"/>
-                <a:cs typeface="Inter" pitchFamily="34" charset="-120"/>
-              </a:rPr>
-              <a:t>[4] J. Cheney, A. Ahmed, U. A. Acar, “Provenance as dependency analysis,” Mathematical Structures in Computer Science, vol. 21, no. 6, pp. 1301–1337, 2011. doi:10.1017/S0960129511000211</a:t>
-            </a:r>
-            <a:endParaRPr lang="en-US" sz="1600" dirty="0"/>
-          </a:p>
-          <a:p>
-            <a:pPr indent="0" marL="0">
-              <a:spcAft>
-                <a:spcPts val="900"/>
-              </a:spcAft>
-              <a:buNone/>
-            </a:pPr>
-            <a:r>
-              <a:rPr lang="en-US" sz="1300" dirty="0">
-                <a:solidFill>
-                  <a:srgbClr val="ECECEE"/>
-                </a:solidFill>
-                <a:latin typeface="Inter" pitchFamily="34" charset="0"/>
-                <a:ea typeface="Inter" pitchFamily="34" charset="-122"/>
-                <a:cs typeface="Inter" pitchFamily="34" charset="-120"/>
-              </a:rPr>
-              <a:t>[5] A. J. Ko, B. A. Myers, “Designing the Whyline: A Debugging Interface for Asking Questions About Program Behavior,” CHI 2004, Vienna, pp. 151–158.</a:t>
-            </a:r>
-            <a:endParaRPr lang="en-US" sz="1600" dirty="0"/>
-          </a:p>
-        </p:txBody>
-      </p:sp>
-      <p:sp>
-        <p:nvSpPr>
-          <p:cNvPr id="7" name="card-527"/>
+        </p:txBody>
+      </p:sp>
+      <p:sp>
+        <p:nvSpPr>
+          <p:cNvPr id="8" name="card-520"/>
           <p:cNvSpPr/>
           <p:nvPr/>
         </p:nvSpPr>
         <p:spPr>
           <a:xfrm>
-            <a:off x="6199632" y="1280160"/>
-            <a:ext cx="5440680" cy="4892040"/>
+            <a:off x="4389120" y="2651760"/>
+            <a:ext cx="3474720" cy="2103120"/>
           </a:xfrm>
           <a:prstGeom prst="roundRect">
             <a:avLst>
-              <a:gd name="adj" fmla="val 1495"/>
+              <a:gd name="adj" fmla="val 3478"/>
             </a:avLst>
           </a:prstGeom>
           <a:solidFill>
@@ -17545,7 +17616,912 @@
       </p:sp>
       <p:sp>
         <p:nvSpPr>
-          <p:cNvPr id="8" name="text-528"/>
+          <p:cNvPr id="9" name="text-521"/>
+          <p:cNvSpPr txBox="1"/>
+          <p:nvPr/>
+        </p:nvSpPr>
+        <p:spPr>
+          <a:xfrm>
+            <a:off x="4617720" y="2788920"/>
+            <a:ext cx="3017520" cy="365760"/>
+          </a:xfrm>
+          <a:prstGeom prst="rect">
+            <a:avLst/>
+          </a:prstGeom>
+          <a:noFill/>
+          <a:ln/>
+        </p:spPr>
+        <p:txBody>
+          <a:bodyPr wrap="square" lIns="0" tIns="0" rIns="0" bIns="0" rtlCol="0" anchor="t"/>
+          <a:lstStyle/>
+          <a:p>
+            <a:pPr indent="0" marL="0">
+              <a:buNone/>
+            </a:pPr>
+            <a:r>
+              <a:rPr lang="en-US" sz="1600" b="1" dirty="0">
+                <a:solidFill>
+                  <a:srgbClr val="7C7C84"/>
+                </a:solidFill>
+                <a:latin typeface="Consolas" pitchFamily="34" charset="0"/>
+                <a:ea typeface="Consolas" pitchFamily="34" charset="-122"/>
+                <a:cs typeface="Consolas" pitchFamily="34" charset="-120"/>
+              </a:rPr>
+              <a:t>impact</a:t>
+            </a:r>
+            <a:endParaRPr lang="en-US" sz="1600" dirty="0"/>
+          </a:p>
+        </p:txBody>
+      </p:sp>
+      <p:sp>
+        <p:nvSpPr>
+          <p:cNvPr id="10" name="text-522"/>
+          <p:cNvSpPr txBox="1"/>
+          <p:nvPr/>
+        </p:nvSpPr>
+        <p:spPr>
+          <a:xfrm>
+            <a:off x="4617720" y="3200400"/>
+            <a:ext cx="3017520" cy="457200"/>
+          </a:xfrm>
+          <a:prstGeom prst="rect">
+            <a:avLst/>
+          </a:prstGeom>
+          <a:noFill/>
+          <a:ln/>
+        </p:spPr>
+        <p:txBody>
+          <a:bodyPr wrap="square" lIns="0" tIns="0" rIns="0" bIns="0" rtlCol="0" anchor="t"/>
+          <a:lstStyle/>
+          <a:p>
+            <a:pPr indent="0" marL="0">
+              <a:buNone/>
+            </a:pPr>
+            <a:r>
+              <a:rPr lang="en-US" sz="2400" b="1" dirty="0">
+                <a:solidFill>
+                  <a:srgbClr val="22D3EE"/>
+                </a:solidFill>
+                <a:latin typeface="Inter" pitchFamily="34" charset="0"/>
+                <a:ea typeface="Inter" pitchFamily="34" charset="-122"/>
+                <a:cs typeface="Inter" pitchFamily="34" charset="-120"/>
+              </a:rPr>
+              <a:t>Trace</a:t>
+            </a:r>
+            <a:endParaRPr lang="en-US" sz="2400" dirty="0"/>
+          </a:p>
+        </p:txBody>
+      </p:sp>
+      <p:sp>
+        <p:nvSpPr>
+          <p:cNvPr id="11" name="text-523"/>
+          <p:cNvSpPr txBox="1"/>
+          <p:nvPr/>
+        </p:nvSpPr>
+        <p:spPr>
+          <a:xfrm>
+            <a:off x="4617720" y="3703320"/>
+            <a:ext cx="3017520" cy="914400"/>
+          </a:xfrm>
+          <a:prstGeom prst="rect">
+            <a:avLst/>
+          </a:prstGeom>
+          <a:noFill/>
+          <a:ln/>
+        </p:spPr>
+        <p:txBody>
+          <a:bodyPr wrap="square" lIns="0" tIns="0" rIns="0" bIns="0" rtlCol="0" anchor="t"/>
+          <a:lstStyle/>
+          <a:p>
+            <a:pPr indent="0" marL="0">
+              <a:buNone/>
+            </a:pPr>
+            <a:r>
+              <a:rPr lang="en-US" sz="1600" dirty="0">
+                <a:solidFill>
+                  <a:srgbClr val="ECECEE"/>
+                </a:solidFill>
+                <a:latin typeface="Inter" pitchFamily="34" charset="0"/>
+                <a:ea typeface="Inter" pitchFamily="34" charset="-122"/>
+                <a:cs typeface="Inter" pitchFamily="34" charset="-120"/>
+              </a:rPr>
+              <a:t>the impact of a binding</a:t>
+            </a:r>
+            <a:endParaRPr lang="en-US" sz="1600" dirty="0"/>
+          </a:p>
+        </p:txBody>
+      </p:sp>
+      <p:sp>
+        <p:nvSpPr>
+          <p:cNvPr id="12" name="card-524"/>
+          <p:cNvSpPr/>
+          <p:nvPr/>
+        </p:nvSpPr>
+        <p:spPr>
+          <a:xfrm>
+            <a:off x="8046720" y="2651760"/>
+            <a:ext cx="3474720" cy="2103120"/>
+          </a:xfrm>
+          <a:prstGeom prst="roundRect">
+            <a:avLst>
+              <a:gd name="adj" fmla="val 3478"/>
+            </a:avLst>
+          </a:prstGeom>
+          <a:solidFill>
+            <a:srgbClr val="121214"/>
+          </a:solidFill>
+          <a:ln w="12700">
+            <a:solidFill>
+              <a:srgbClr val="2B2B31"/>
+            </a:solidFill>
+            <a:prstDash val="solid"/>
+          </a:ln>
+        </p:spPr>
+      </p:sp>
+      <p:sp>
+        <p:nvSpPr>
+          <p:cNvPr id="13" name="text-525"/>
+          <p:cNvSpPr txBox="1"/>
+          <p:nvPr/>
+        </p:nvSpPr>
+        <p:spPr>
+          <a:xfrm>
+            <a:off x="8275320" y="2788920"/>
+            <a:ext cx="3017520" cy="365760"/>
+          </a:xfrm>
+          <a:prstGeom prst="rect">
+            <a:avLst/>
+          </a:prstGeom>
+          <a:noFill/>
+          <a:ln/>
+        </p:spPr>
+        <p:txBody>
+          <a:bodyPr wrap="square" lIns="0" tIns="0" rIns="0" bIns="0" rtlCol="0" anchor="t"/>
+          <a:lstStyle/>
+          <a:p>
+            <a:pPr indent="0" marL="0">
+              <a:buNone/>
+            </a:pPr>
+            <a:r>
+              <a:rPr lang="en-US" sz="1600" b="1" dirty="0">
+                <a:solidFill>
+                  <a:srgbClr val="7C7C84"/>
+                </a:solidFill>
+                <a:latin typeface="Consolas" pitchFamily="34" charset="0"/>
+                <a:ea typeface="Consolas" pitchFamily="34" charset="-122"/>
+                <a:cs typeface="Consolas" pitchFamily="34" charset="-120"/>
+              </a:rPr>
+              <a:t>whatif</a:t>
+            </a:r>
+            <a:endParaRPr lang="en-US" sz="1600" dirty="0"/>
+          </a:p>
+        </p:txBody>
+      </p:sp>
+      <p:sp>
+        <p:nvSpPr>
+          <p:cNvPr id="14" name="text-526"/>
+          <p:cNvSpPr txBox="1"/>
+          <p:nvPr/>
+        </p:nvSpPr>
+        <p:spPr>
+          <a:xfrm>
+            <a:off x="8275320" y="3200400"/>
+            <a:ext cx="3017520" cy="457200"/>
+          </a:xfrm>
+          <a:prstGeom prst="rect">
+            <a:avLst/>
+          </a:prstGeom>
+          <a:noFill/>
+          <a:ln/>
+        </p:spPr>
+        <p:txBody>
+          <a:bodyPr wrap="square" lIns="0" tIns="0" rIns="0" bIns="0" rtlCol="0" anchor="t"/>
+          <a:lstStyle/>
+          <a:p>
+            <a:pPr indent="0" marL="0">
+              <a:buNone/>
+            </a:pPr>
+            <a:r>
+              <a:rPr lang="en-US" sz="2400" b="1" dirty="0">
+                <a:solidFill>
+                  <a:srgbClr val="22D3EE"/>
+                </a:solidFill>
+                <a:latin typeface="Inter" pitchFamily="34" charset="0"/>
+                <a:ea typeface="Inter" pitchFamily="34" charset="-122"/>
+                <a:cs typeface="Inter" pitchFamily="34" charset="-120"/>
+              </a:rPr>
+              <a:t>Explore</a:t>
+            </a:r>
+            <a:endParaRPr lang="en-US" sz="2400" dirty="0"/>
+          </a:p>
+        </p:txBody>
+      </p:sp>
+      <p:sp>
+        <p:nvSpPr>
+          <p:cNvPr id="15" name="text-527"/>
+          <p:cNvSpPr txBox="1"/>
+          <p:nvPr/>
+        </p:nvSpPr>
+        <p:spPr>
+          <a:xfrm>
+            <a:off x="8275320" y="3703320"/>
+            <a:ext cx="3017520" cy="914400"/>
+          </a:xfrm>
+          <a:prstGeom prst="rect">
+            <a:avLst/>
+          </a:prstGeom>
+          <a:noFill/>
+          <a:ln/>
+        </p:spPr>
+        <p:txBody>
+          <a:bodyPr wrap="square" lIns="0" tIns="0" rIns="0" bIns="0" rtlCol="0" anchor="t"/>
+          <a:lstStyle/>
+          <a:p>
+            <a:pPr indent="0" marL="0">
+              <a:buNone/>
+            </a:pPr>
+            <a:r>
+              <a:rPr lang="en-US" sz="1600" dirty="0">
+                <a:solidFill>
+                  <a:srgbClr val="ECECEE"/>
+                </a:solidFill>
+                <a:latin typeface="Inter" pitchFamily="34" charset="0"/>
+                <a:ea typeface="Inter" pitchFamily="34" charset="-122"/>
+                <a:cs typeface="Inter" pitchFamily="34" charset="-120"/>
+              </a:rPr>
+              <a:t>alternative inputs without changing the original execution</a:t>
+            </a:r>
+            <a:endParaRPr lang="en-US" sz="1600" dirty="0"/>
+          </a:p>
+        </p:txBody>
+      </p:sp>
+      <p:sp>
+        <p:nvSpPr>
+          <p:cNvPr id="16" name="text-528"/>
+          <p:cNvSpPr txBox="1"/>
+          <p:nvPr/>
+        </p:nvSpPr>
+        <p:spPr>
+          <a:xfrm>
+            <a:off x="731520" y="4846320"/>
+            <a:ext cx="5486400" cy="822960"/>
+          </a:xfrm>
+          <a:prstGeom prst="rect">
+            <a:avLst/>
+          </a:prstGeom>
+          <a:noFill/>
+          <a:ln/>
+        </p:spPr>
+        <p:txBody>
+          <a:bodyPr wrap="square" lIns="0" tIns="0" rIns="0" bIns="0" rtlCol="0" anchor="ctr"/>
+          <a:lstStyle/>
+          <a:p>
+            <a:pPr indent="0" marL="0">
+              <a:buNone/>
+            </a:pPr>
+            <a:r>
+              <a:rPr lang="en-US" sz="4800" b="1" dirty="0">
+                <a:solidFill>
+                  <a:srgbClr val="ECECEE"/>
+                </a:solidFill>
+                <a:latin typeface="Inter" pitchFamily="34" charset="0"/>
+                <a:ea typeface="Inter" pitchFamily="34" charset="-122"/>
+                <a:cs typeface="Inter" pitchFamily="34" charset="-120"/>
+              </a:rPr>
+              <a:t>Questions?</a:t>
+            </a:r>
+            <a:endParaRPr lang="en-US" sz="4800" dirty="0"/>
+          </a:p>
+        </p:txBody>
+      </p:sp>
+      <p:sp>
+        <p:nvSpPr>
+          <p:cNvPr id="17" name="text-529"/>
+          <p:cNvSpPr txBox="1"/>
+          <p:nvPr/>
+        </p:nvSpPr>
+        <p:spPr>
+          <a:xfrm>
+            <a:off x="731520" y="5760720"/>
+            <a:ext cx="6400800" cy="411480"/>
+          </a:xfrm>
+          <a:prstGeom prst="rect">
+            <a:avLst/>
+          </a:prstGeom>
+          <a:noFill/>
+          <a:ln/>
+        </p:spPr>
+        <p:txBody>
+          <a:bodyPr wrap="square" lIns="0" tIns="0" rIns="0" bIns="0" rtlCol="0" anchor="ctr"/>
+          <a:lstStyle/>
+          <a:p>
+            <a:pPr indent="0" marL="0">
+              <a:buNone/>
+            </a:pPr>
+            <a:r>
+              <a:rPr lang="en-US" sz="2000" b="1" u="sng" dirty="0">
+                <a:solidFill>
+                  <a:srgbClr val="22D3EE"/>
+                </a:solidFill>
+                <a:uFill>
+                  <a:solidFill>
+                    <a:srgbClr val="22D3EE"/>
+                  </a:solidFill>
+                </a:uFill>
+                <a:latin typeface="Inter" pitchFamily="34" charset="0"/>
+                <a:ea typeface="Inter" pitchFamily="34" charset="-122"/>
+                <a:cs typeface="Inter" pitchFamily="34" charset="-120"/>
+                <a:hlinkClick r:id="rId1" invalidUrl="" action="" tgtFrame="" tooltip="CAUSA source code" history="1" highlightClick="0" endSnd="0">
+                  <a:extLst>
+                    <a:ext uri="{A12FA001-AC4F-418D-AE19-62706E023703}">
+                      <ahyp:hlinkClr xmlns:ahyp="http://schemas.microsoft.com/office/drawing/2018/hyperlinkcolor" val="tx"/>
+                    </a:ext>
+                  </a:extLst>
+                </a:hlinkClick>
+              </a:rPr>
+              <a:t>github.com/ujvall/causa</a:t>
+            </a:r>
+            <a:endParaRPr lang="en-US" sz="2000" dirty="0"/>
+          </a:p>
+        </p:txBody>
+      </p:sp>
+      <p:sp>
+        <p:nvSpPr>
+          <p:cNvPr id="18" name="panel-530"/>
+          <p:cNvSpPr/>
+          <p:nvPr/>
+        </p:nvSpPr>
+        <p:spPr>
+          <a:xfrm>
+            <a:off x="7589520" y="4983480"/>
+            <a:ext cx="4050792" cy="1417320"/>
+          </a:xfrm>
+          <a:prstGeom prst="roundRect">
+            <a:avLst>
+              <a:gd name="adj" fmla="val 5161"/>
+            </a:avLst>
+          </a:prstGeom>
+          <a:solidFill>
+            <a:srgbClr val="121214"/>
+          </a:solidFill>
+          <a:ln w="12700">
+            <a:solidFill>
+              <a:srgbClr val="121214"/>
+            </a:solidFill>
+            <a:prstDash val="solid"/>
+          </a:ln>
+        </p:spPr>
+      </p:sp>
+      <p:sp>
+        <p:nvSpPr>
+          <p:cNvPr id="19" name="arrow-531"/>
+          <p:cNvSpPr/>
+          <p:nvPr/>
+        </p:nvSpPr>
+        <p:spPr>
+          <a:xfrm flipV="1">
+            <a:off x="8869680" y="5532120"/>
+            <a:ext cx="274320" cy="228600"/>
+          </a:xfrm>
+          <a:prstGeom prst="line">
+            <a:avLst/>
+          </a:prstGeom>
+          <a:noFill/>
+          <a:ln w="19050">
+            <a:solidFill>
+              <a:srgbClr val="8E8E96"/>
+            </a:solidFill>
+            <a:prstDash val="solid"/>
+            <a:tailEnd type="triangle"/>
+          </a:ln>
+        </p:spPr>
+      </p:sp>
+      <p:sp>
+        <p:nvSpPr>
+          <p:cNvPr id="20" name="arrow-532"/>
+          <p:cNvSpPr/>
+          <p:nvPr/>
+        </p:nvSpPr>
+        <p:spPr>
+          <a:xfrm>
+            <a:off x="10241280" y="5532120"/>
+            <a:ext cx="182880" cy="228600"/>
+          </a:xfrm>
+          <a:prstGeom prst="line">
+            <a:avLst/>
+          </a:prstGeom>
+          <a:noFill/>
+          <a:ln w="19050">
+            <a:solidFill>
+              <a:srgbClr val="8E8E96"/>
+            </a:solidFill>
+            <a:prstDash val="solid"/>
+            <a:tailEnd type="triangle"/>
+          </a:ln>
+        </p:spPr>
+      </p:sp>
+      <p:sp>
+        <p:nvSpPr>
+          <p:cNvPr id="21" name="node-533"/>
+          <p:cNvSpPr/>
+          <p:nvPr/>
+        </p:nvSpPr>
+        <p:spPr>
+          <a:xfrm>
+            <a:off x="7772400" y="5486400"/>
+            <a:ext cx="1097280" cy="548640"/>
+          </a:xfrm>
+          <a:prstGeom prst="roundRect">
+            <a:avLst>
+              <a:gd name="adj" fmla="val 10000"/>
+            </a:avLst>
+          </a:prstGeom>
+          <a:solidFill>
+            <a:srgbClr val="1C1C21"/>
+          </a:solidFill>
+          <a:ln w="19050">
+            <a:solidFill>
+              <a:srgbClr val="86EFAC"/>
+            </a:solidFill>
+            <a:prstDash val="solid"/>
+          </a:ln>
+        </p:spPr>
+      </p:sp>
+      <p:sp>
+        <p:nvSpPr>
+          <p:cNvPr id="22" name="text-534"/>
+          <p:cNvSpPr txBox="1"/>
+          <p:nvPr/>
+        </p:nvSpPr>
+        <p:spPr>
+          <a:xfrm>
+            <a:off x="7772400" y="5486400"/>
+            <a:ext cx="1097280" cy="548640"/>
+          </a:xfrm>
+          <a:prstGeom prst="rect">
+            <a:avLst/>
+          </a:prstGeom>
+          <a:noFill/>
+          <a:ln/>
+        </p:spPr>
+        <p:txBody>
+          <a:bodyPr wrap="square" lIns="0" tIns="0" rIns="0" bIns="0" rtlCol="0" anchor="ctr"/>
+          <a:lstStyle/>
+          <a:p>
+            <a:pPr algn="ctr" indent="0" marL="0">
+              <a:buNone/>
+            </a:pPr>
+            <a:r>
+              <a:rPr lang="en-US" sz="1400" b="1" dirty="0">
+                <a:solidFill>
+                  <a:srgbClr val="ECECEE"/>
+                </a:solidFill>
+                <a:latin typeface="Consolas" pitchFamily="34" charset="0"/>
+                <a:ea typeface="Consolas" pitchFamily="34" charset="-122"/>
+                <a:cs typeface="Consolas" pitchFamily="34" charset="-120"/>
+              </a:rPr>
+              <a:t>price</a:t>
+            </a:r>
+            <a:endParaRPr lang="en-US" sz="1400" dirty="0"/>
+          </a:p>
+        </p:txBody>
+      </p:sp>
+      <p:sp>
+        <p:nvSpPr>
+          <p:cNvPr id="23" name="node-535"/>
+          <p:cNvSpPr/>
+          <p:nvPr/>
+        </p:nvSpPr>
+        <p:spPr>
+          <a:xfrm>
+            <a:off x="9144000" y="5257800"/>
+            <a:ext cx="1097280" cy="548640"/>
+          </a:xfrm>
+          <a:prstGeom prst="roundRect">
+            <a:avLst>
+              <a:gd name="adj" fmla="val 10000"/>
+            </a:avLst>
+          </a:prstGeom>
+          <a:solidFill>
+            <a:srgbClr val="1C1C21"/>
+          </a:solidFill>
+          <a:ln w="19050">
+            <a:solidFill>
+              <a:srgbClr val="60A5FA"/>
+            </a:solidFill>
+            <a:prstDash val="solid"/>
+          </a:ln>
+        </p:spPr>
+      </p:sp>
+      <p:sp>
+        <p:nvSpPr>
+          <p:cNvPr id="24" name="text-536"/>
+          <p:cNvSpPr txBox="1"/>
+          <p:nvPr/>
+        </p:nvSpPr>
+        <p:spPr>
+          <a:xfrm>
+            <a:off x="9144000" y="5257800"/>
+            <a:ext cx="1097280" cy="548640"/>
+          </a:xfrm>
+          <a:prstGeom prst="rect">
+            <a:avLst/>
+          </a:prstGeom>
+          <a:noFill/>
+          <a:ln/>
+        </p:spPr>
+        <p:txBody>
+          <a:bodyPr wrap="square" lIns="0" tIns="0" rIns="0" bIns="0" rtlCol="0" anchor="ctr"/>
+          <a:lstStyle/>
+          <a:p>
+            <a:pPr algn="ctr" indent="0" marL="0">
+              <a:buNone/>
+            </a:pPr>
+            <a:r>
+              <a:rPr lang="en-US" sz="1400" b="1" dirty="0">
+                <a:solidFill>
+                  <a:srgbClr val="ECECEE"/>
+                </a:solidFill>
+                <a:latin typeface="Consolas" pitchFamily="34" charset="0"/>
+                <a:ea typeface="Consolas" pitchFamily="34" charset="-122"/>
+                <a:cs typeface="Consolas" pitchFamily="34" charset="-120"/>
+              </a:rPr>
+              <a:t>savings</a:t>
+            </a:r>
+            <a:endParaRPr lang="en-US" sz="1400" dirty="0"/>
+          </a:p>
+        </p:txBody>
+      </p:sp>
+      <p:sp>
+        <p:nvSpPr>
+          <p:cNvPr id="25" name="node-537"/>
+          <p:cNvSpPr/>
+          <p:nvPr/>
+        </p:nvSpPr>
+        <p:spPr>
+          <a:xfrm>
+            <a:off x="10424160" y="5486400"/>
+            <a:ext cx="1097280" cy="548640"/>
+          </a:xfrm>
+          <a:prstGeom prst="roundRect">
+            <a:avLst>
+              <a:gd name="adj" fmla="val 10000"/>
+            </a:avLst>
+          </a:prstGeom>
+          <a:solidFill>
+            <a:srgbClr val="1C1C21"/>
+          </a:solidFill>
+          <a:ln w="19050">
+            <a:solidFill>
+              <a:srgbClr val="22D3EE"/>
+            </a:solidFill>
+            <a:prstDash val="solid"/>
+          </a:ln>
+        </p:spPr>
+      </p:sp>
+      <p:sp>
+        <p:nvSpPr>
+          <p:cNvPr id="26" name="text-538"/>
+          <p:cNvSpPr txBox="1"/>
+          <p:nvPr/>
+        </p:nvSpPr>
+        <p:spPr>
+          <a:xfrm>
+            <a:off x="10424160" y="5486400"/>
+            <a:ext cx="1097280" cy="548640"/>
+          </a:xfrm>
+          <a:prstGeom prst="rect">
+            <a:avLst/>
+          </a:prstGeom>
+          <a:noFill/>
+          <a:ln/>
+        </p:spPr>
+        <p:txBody>
+          <a:bodyPr wrap="square" lIns="0" tIns="0" rIns="0" bIns="0" rtlCol="0" anchor="ctr"/>
+          <a:lstStyle/>
+          <a:p>
+            <a:pPr algn="ctr" indent="0" marL="0">
+              <a:buNone/>
+            </a:pPr>
+            <a:r>
+              <a:rPr lang="en-US" sz="1400" b="1" dirty="0">
+                <a:solidFill>
+                  <a:srgbClr val="ECECEE"/>
+                </a:solidFill>
+                <a:latin typeface="Consolas" pitchFamily="34" charset="0"/>
+                <a:ea typeface="Consolas" pitchFamily="34" charset="-122"/>
+                <a:cs typeface="Consolas" pitchFamily="34" charset="-120"/>
+              </a:rPr>
+              <a:t>total</a:t>
+            </a:r>
+            <a:endParaRPr lang="en-US" sz="1400" dirty="0"/>
+          </a:p>
+        </p:txBody>
+      </p:sp>
+    </p:spTree>
+  </p:cSld>
+  <p:clrMapOvr>
+    <a:masterClrMapping/>
+  </p:clrMapOvr>
+</p:sld>
+</file>
+
+<file path=ppt/slides/slide21.xml><?xml version="1.0" encoding="utf-8"?>
+<p:sld xmlns:a="http://schemas.openxmlformats.org/drawingml/2006/main" xmlns:r="http://schemas.openxmlformats.org/officeDocument/2006/relationships" xmlns:p="http://schemas.openxmlformats.org/presentationml/2006/main">
+  <p:cSld name="Slide 21">
+    <p:spTree>
+      <p:nvGrpSpPr>
+        <p:cNvPr id="1" name=""/>
+        <p:cNvGrpSpPr/>
+        <p:nvPr/>
+      </p:nvGrpSpPr>
+      <p:grpSpPr>
+        <a:xfrm>
+          <a:off x="0" y="0"/>
+          <a:ext cx="0" cy="0"/>
+          <a:chOff x="0" y="0"/>
+          <a:chExt cx="0" cy="0"/>
+        </a:xfrm>
+      </p:grpSpPr>
+      <p:sp>
+        <p:nvSpPr>
+          <p:cNvPr id="2" name="Text 0"/>
+          <p:cNvSpPr/>
+          <p:nvPr>
+            <p:ph idx="100" type="title" hasCustomPrompt="1"/>
+          </p:nvPr>
+        </p:nvSpPr>
+        <p:spPr>
+          <a:xfrm>
+            <a:off x="548640" y="365760"/>
+            <a:ext cx="11091672" cy="685800"/>
+          </a:xfrm>
+          <a:prstGeom prst="rect">
+            <a:avLst/>
+          </a:prstGeom>
+          <a:noFill/>
+          <a:ln/>
+        </p:spPr>
+        <p:txBody>
+          <a:bodyPr wrap="square" lIns="0" tIns="0" rIns="0" bIns="0" rtlCol="0" anchor="t"/>
+          <a:lstStyle/>
+          <a:p>
+            <a:pPr algn="l" indent="0" marL="0">
+              <a:buNone/>
+            </a:pPr>
+            <a:r>
+              <a:rPr lang="en-US" sz="2800" b="1" spc="-50" kern="0" dirty="0">
+                <a:solidFill>
+                  <a:srgbClr val="ECECEE"/>
+                </a:solidFill>
+                <a:latin typeface="Inter" pitchFamily="34" charset="0"/>
+                <a:ea typeface="Inter" pitchFamily="34" charset="-122"/>
+                <a:cs typeface="Inter" pitchFamily="34" charset="-120"/>
+              </a:rPr>
+              <a:t>Appendix: references</a:t>
+            </a:r>
+            <a:endParaRPr lang="en-US" sz="2800" dirty="0"/>
+          </a:p>
+        </p:txBody>
+      </p:sp>
+      <p:sp>
+        <p:nvSpPr>
+          <p:cNvPr id="3" name="text-539"/>
+          <p:cNvSpPr txBox="1"/>
+          <p:nvPr/>
+        </p:nvSpPr>
+        <p:spPr>
+          <a:xfrm>
+            <a:off x="548640" y="6446520"/>
+            <a:ext cx="5486400" cy="274320"/>
+          </a:xfrm>
+          <a:prstGeom prst="rect">
+            <a:avLst/>
+          </a:prstGeom>
+          <a:noFill/>
+          <a:ln/>
+        </p:spPr>
+        <p:txBody>
+          <a:bodyPr wrap="square" lIns="0" tIns="0" rIns="0" bIns="0" rtlCol="0" anchor="t"/>
+          <a:lstStyle/>
+          <a:p>
+            <a:pPr indent="0" marL="0">
+              <a:buNone/>
+            </a:pPr>
+            <a:r>
+              <a:rPr lang="en-US" sz="1000" dirty="0">
+                <a:solidFill>
+                  <a:srgbClr val="7C7C84"/>
+                </a:solidFill>
+                <a:latin typeface="Inter" pitchFamily="34" charset="0"/>
+                <a:ea typeface="Inter" pitchFamily="34" charset="-122"/>
+                <a:cs typeface="Inter" pitchFamily="34" charset="-120"/>
+              </a:rPr>
+              <a:t>CAUSA   Closing</a:t>
+            </a:r>
+            <a:endParaRPr lang="en-US" sz="1000" dirty="0"/>
+          </a:p>
+        </p:txBody>
+      </p:sp>
+      <p:sp>
+        <p:nvSpPr>
+          <p:cNvPr id="5" name="card-540"/>
+          <p:cNvSpPr/>
+          <p:nvPr/>
+        </p:nvSpPr>
+        <p:spPr>
+          <a:xfrm>
+            <a:off x="548640" y="1280160"/>
+            <a:ext cx="5440680" cy="4892040"/>
+          </a:xfrm>
+          <a:prstGeom prst="roundRect">
+            <a:avLst>
+              <a:gd name="adj" fmla="val 1495"/>
+            </a:avLst>
+          </a:prstGeom>
+          <a:solidFill>
+            <a:srgbClr val="121214"/>
+          </a:solidFill>
+          <a:ln w="12700">
+            <a:solidFill>
+              <a:srgbClr val="2B2B31"/>
+            </a:solidFill>
+            <a:prstDash val="solid"/>
+          </a:ln>
+        </p:spPr>
+      </p:sp>
+      <p:sp>
+        <p:nvSpPr>
+          <p:cNvPr id="6" name="text-541"/>
+          <p:cNvSpPr txBox="1"/>
+          <p:nvPr/>
+        </p:nvSpPr>
+        <p:spPr>
+          <a:xfrm>
+            <a:off x="731520" y="1417320"/>
+            <a:ext cx="5120640" cy="4663440"/>
+          </a:xfrm>
+          <a:prstGeom prst="rect">
+            <a:avLst/>
+          </a:prstGeom>
+          <a:noFill/>
+          <a:ln/>
+        </p:spPr>
+        <p:txBody>
+          <a:bodyPr wrap="square" lIns="0" tIns="0" rIns="0" bIns="0" rtlCol="0" anchor="t"/>
+          <a:lstStyle/>
+          <a:p>
+            <a:pPr indent="0" marL="0">
+              <a:spcAft>
+                <a:spcPts val="900"/>
+              </a:spcAft>
+              <a:buNone/>
+            </a:pPr>
+            <a:r>
+              <a:rPr lang="en-US" sz="1300" dirty="0">
+                <a:solidFill>
+                  <a:srgbClr val="ECECEE"/>
+                </a:solidFill>
+                <a:latin typeface="Inter" pitchFamily="34" charset="0"/>
+                <a:ea typeface="Inter" pitchFamily="34" charset="-122"/>
+                <a:cs typeface="Inter" pitchFamily="34" charset="-120"/>
+              </a:rPr>
+              <a:t>[1] M. Weiser, “Program Slicing,” IEEE Transactions on Software Engineering, vol. 10, no. 4, pp. 352–357, 1984.</a:t>
+            </a:r>
+            <a:endParaRPr lang="en-US" sz="1600" dirty="0"/>
+          </a:p>
+          <a:p>
+            <a:pPr indent="0" marL="0">
+              <a:spcAft>
+                <a:spcPts val="900"/>
+              </a:spcAft>
+              <a:buNone/>
+            </a:pPr>
+            <a:r>
+              <a:rPr lang="en-US" sz="1300" dirty="0">
+                <a:solidFill>
+                  <a:srgbClr val="ECECEE"/>
+                </a:solidFill>
+                <a:latin typeface="Inter" pitchFamily="34" charset="0"/>
+                <a:ea typeface="Inter" pitchFamily="34" charset="-122"/>
+                <a:cs typeface="Inter" pitchFamily="34" charset="-120"/>
+              </a:rPr>
+              <a:t>[2] J. Ferrante, K. J. Ottenstein, J. D. Warren, “The Program Dependence Graph and Its Use in Optimization,” ACM TOPLAS, vol. 9, no. 3, pp. 319–349, 1987. doi:10.1145/24039.24041</a:t>
+            </a:r>
+            <a:endParaRPr lang="en-US" sz="1600" dirty="0"/>
+          </a:p>
+          <a:p>
+            <a:pPr indent="0" marL="0">
+              <a:spcAft>
+                <a:spcPts val="900"/>
+              </a:spcAft>
+              <a:buNone/>
+            </a:pPr>
+            <a:r>
+              <a:rPr lang="en-US" sz="1300" dirty="0">
+                <a:solidFill>
+                  <a:srgbClr val="ECECEE"/>
+                </a:solidFill>
+                <a:latin typeface="Inter" pitchFamily="34" charset="0"/>
+                <a:ea typeface="Inter" pitchFamily="34" charset="-122"/>
+                <a:cs typeface="Inter" pitchFamily="34" charset="-120"/>
+              </a:rPr>
+              <a:t>[3] J. Cheney, L. Chiticariu, W.-C. Tan, “Provenance in Databases: Why, How, and Where,” Foundations and Trends in Databases, vol. 1, no. 4, pp. 379–474, 2009. doi:10.1561/1900000006</a:t>
+            </a:r>
+            <a:endParaRPr lang="en-US" sz="1600" dirty="0"/>
+          </a:p>
+          <a:p>
+            <a:pPr indent="0" marL="0">
+              <a:spcAft>
+                <a:spcPts val="900"/>
+              </a:spcAft>
+              <a:buNone/>
+            </a:pPr>
+            <a:r>
+              <a:rPr lang="en-US" sz="1300" dirty="0">
+                <a:solidFill>
+                  <a:srgbClr val="ECECEE"/>
+                </a:solidFill>
+                <a:latin typeface="Inter" pitchFamily="34" charset="0"/>
+                <a:ea typeface="Inter" pitchFamily="34" charset="-122"/>
+                <a:cs typeface="Inter" pitchFamily="34" charset="-120"/>
+              </a:rPr>
+              <a:t>[4] J. Cheney, A. Ahmed, U. A. Acar, “Provenance as dependency analysis,” Mathematical Structures in Computer Science, vol. 21, no. 6, pp. 1301–1337, 2011. doi:10.1017/S0960129511000211</a:t>
+            </a:r>
+            <a:endParaRPr lang="en-US" sz="1600" dirty="0"/>
+          </a:p>
+          <a:p>
+            <a:pPr indent="0" marL="0">
+              <a:spcAft>
+                <a:spcPts val="900"/>
+              </a:spcAft>
+              <a:buNone/>
+            </a:pPr>
+            <a:r>
+              <a:rPr lang="en-US" sz="1300" dirty="0">
+                <a:solidFill>
+                  <a:srgbClr val="ECECEE"/>
+                </a:solidFill>
+                <a:latin typeface="Inter" pitchFamily="34" charset="0"/>
+                <a:ea typeface="Inter" pitchFamily="34" charset="-122"/>
+                <a:cs typeface="Inter" pitchFamily="34" charset="-120"/>
+              </a:rPr>
+              <a:t>[5] A. J. Ko, B. A. Myers, “Designing the Whyline: A Debugging Interface for Asking Questions About Program Behavior,” CHI 2004, Vienna, pp. 151–158.</a:t>
+            </a:r>
+            <a:endParaRPr lang="en-US" sz="1600" dirty="0"/>
+          </a:p>
+        </p:txBody>
+      </p:sp>
+      <p:sp>
+        <p:nvSpPr>
+          <p:cNvPr id="7" name="card-542"/>
+          <p:cNvSpPr/>
+          <p:nvPr/>
+        </p:nvSpPr>
+        <p:spPr>
+          <a:xfrm>
+            <a:off x="6199632" y="1280160"/>
+            <a:ext cx="5440680" cy="4892040"/>
+          </a:xfrm>
+          <a:prstGeom prst="roundRect">
+            <a:avLst>
+              <a:gd name="adj" fmla="val 1495"/>
+            </a:avLst>
+          </a:prstGeom>
+          <a:solidFill>
+            <a:srgbClr val="121214"/>
+          </a:solidFill>
+          <a:ln w="12700">
+            <a:solidFill>
+              <a:srgbClr val="2B2B31"/>
+            </a:solidFill>
+            <a:prstDash val="solid"/>
+          </a:ln>
+        </p:spPr>
+      </p:sp>
+      <p:sp>
+        <p:nvSpPr>
+          <p:cNvPr id="8" name="text-543"/>
           <p:cNvSpPr txBox="1"/>
           <p:nvPr/>
         </p:nvSpPr>
@@ -17707,7 +18683,7 @@
             <a:pPr algn="r"/>
             <a:fld id="{F7021451-1387-4CA6-816F-3879F97B5CBC}" type="slidenum">
               <a:rPr b="0" lang="en-US"/>
-              <a:t>20</a:t>
+              <a:t>21</a:t>
             </a:fld>
             <a:endParaRPr lang="en-US"/>
           </a:p>

</xml_diff>

<commit_message>
Presentation: dedicated GitHub repository slide
</commit_message>
<xml_diff>
--- a/presentation/CAUSA_Final_Presentation.pptx
+++ b/presentation/CAUSA_Final_Presentation.pptx
@@ -26,9 +26,10 @@
     <p:sldId id="274" r:id="rId20"/>
     <p:sldId id="275" r:id="rId21"/>
     <p:sldId id="276" r:id="rId22"/>
+    <p:sldId id="277" r:id="rId23"/>
   </p:sldIdLst>
   <p:notesMasterIdLst>
-    <p:notesMasterId r:id="rId23"/>
+    <p:notesMasterId r:id="rId24"/>
   </p:notesMasterIdLst>
   <p:sldSz cx="12192000" cy="6858000"/>
   <p:notesSz cx="6858000" cy="12192000"/>
@@ -127,12 +128,12 @@
   <p:extLst>
     <p:ext uri="{521415D9-36F7-43E2-AB2F-B90AF26B5E84}">
       <p14:sectionLst xmlns:p14="http://schemas.microsoft.com/office/powerpoint/2010/main">
-        <p14:section name="Opening" id="{d76e2c81-4d64-6d72-e76d-f6412077c4a0}">
+        <p14:section name="Opening" id="{576228eb-e25f-199e-85a6-355e1f6171bb}">
           <p14:sldIdLst>
             <p14:sldId id="256"/>
           </p14:sldIdLst>
         </p14:section>
-        <p14:section name="Problem and idea" id="{dcdcdf44-ce2e-fbd6-9d92-61e056b7130a}">
+        <p14:section name="Problem and idea" id="{afc5c63e-338b-9707-026e-d51f45459380}">
           <p14:sldIdLst>
             <p14:sldId id="257"/>
             <p14:sldId id="258"/>
@@ -141,12 +142,12 @@
             <p14:sldId id="261"/>
           </p14:sldIdLst>
         </p14:section>
-        <p14:section name="Architecture" id="{4f048547-59f9-4722-a12b-1db1ff4a00e4}">
+        <p14:section name="Architecture" id="{71f47193-ac3f-d92c-ae2c-5b2850f95a9d}">
           <p14:sldIdLst>
             <p14:sldId id="262"/>
           </p14:sldIdLst>
         </p14:section>
-        <p14:section name="Demonstration" id="{3b014602-5b1f-e1fd-fc40-176d86fdd865}">
+        <p14:section name="Demonstration" id="{34224976-2755-0bef-722c-98b7495f0eb3}">
           <p14:sldIdLst>
             <p14:sldId id="263"/>
             <p14:sldId id="264"/>
@@ -155,25 +156,26 @@
             <p14:sldId id="267"/>
           </p14:sldIdLst>
         </p14:section>
-        <p14:section name="Internals and Studio" id="{54388091-785a-3582-f0ba-eceaeca10cb1}">
+        <p14:section name="Internals and Studio" id="{e7dfbff5-881e-25bc-868f-e0514a47d5a3}">
           <p14:sldIdLst>
             <p14:sldId id="268"/>
             <p14:sldId id="269"/>
             <p14:sldId id="270"/>
           </p14:sldIdLst>
         </p14:section>
-        <p14:section name="Evaluation" id="{d3cb84cd-d013-e1c4-6fde-3a164a77a437}">
+        <p14:section name="Evaluation" id="{40f6b554-75b3-9813-3faf-7ff37632e95b}">
           <p14:sldIdLst>
             <p14:sldId id="271"/>
             <p14:sldId id="272"/>
           </p14:sldIdLst>
         </p14:section>
-        <p14:section name="Closing" id="{344d42fc-d4a9-927d-2ce6-c86aa786bbc6}">
+        <p14:section name="Closing" id="{bd3cc65d-30db-9410-5bc6-0b26f997c484}">
           <p14:sldIdLst>
             <p14:sldId id="273"/>
             <p14:sldId id="274"/>
             <p14:sldId id="275"/>
             <p14:sldId id="276"/>
+            <p14:sldId id="277"/>
           </p14:sldIdLst>
         </p14:section>
       </p14:sectionLst>
@@ -2058,7 +2060,7 @@
           <a:p>
             <a:r>
               <a:rPr lang="en-US" dirty="0"/>
-              <a:t>Verification: each entry's title, authors, year and venue were checked against a publisher, library or official project page while building this deck. DOIs are given only where a page showed one. Items [1] and [5] show venue, volume and pages but no DOI, because none was confirmed. [7] has a stable official page but no DOI listed there. [8] is the CGO 2021 paper listed on Google Research's publication page; no DOI was confirmed. [10] is an arXiv preprint (not peer reviewed). A Halpern and Pearl structural-model causality paper was considered for the counterfactual theme and dropped because its journal venue could not be verified. Recent sources (2022 to 2024) are [6] (2022) and [10] (2023).</a:t>
+              <a:t>The complete source is public: compiler, C runtime, Studio, tests, benchmarks and documentation. The README has the setup steps, and docs/demonstration.md walks through the pricing example with exact expected output.</a:t>
             </a:r>
             <a:endParaRPr lang="en-US" dirty="0"/>
           </a:p>
@@ -2082,6 +2084,94 @@
             <a:fld id="{F7021451-1387-4CA6-816F-3879F97B5CBC}" type="slidenum">
               <a:rPr lang="en-US"/>
               <a:t>21</a:t>
+            </a:fld>
+            <a:endParaRPr lang="en-US"/>
+          </a:p>
+        </p:txBody>
+      </p:sp>
+    </p:spTree>
+    <p:extLst>
+      <p:ext uri="{BB962C8B-B14F-4D97-AF65-F5344CB8AC3E}">
+        <p14:creationId xmlns:p14="http://schemas.microsoft.com/office/powerpoint/2010/main" val="1024086991"/>
+      </p:ext>
+    </p:extLst>
+  </p:cSld>
+  <p:clrMapOvr>
+    <a:masterClrMapping/>
+  </p:clrMapOvr>
+</p:notes>
+</file>
+
+<file path=ppt/notesSlides/notesSlide22.xml><?xml version="1.0" encoding="utf-8"?>
+<p:notes xmlns:a="http://schemas.openxmlformats.org/drawingml/2006/main" xmlns:r="http://schemas.openxmlformats.org/officeDocument/2006/relationships" xmlns:p="http://schemas.openxmlformats.org/presentationml/2006/main">
+  <p:cSld>
+    <p:spTree>
+      <p:nvGrpSpPr>
+        <p:cNvPr id="1" name=""/>
+        <p:cNvGrpSpPr/>
+        <p:nvPr/>
+      </p:nvGrpSpPr>
+      <p:grpSpPr>
+        <a:xfrm>
+          <a:off x="0" y="0"/>
+          <a:ext cx="0" cy="0"/>
+          <a:chOff x="0" y="0"/>
+          <a:chExt cx="0" cy="0"/>
+        </a:xfrm>
+      </p:grpSpPr>
+      <p:sp>
+        <p:nvSpPr>
+          <p:cNvPr id="2" name="Slide Image Placeholder 1"/>
+          <p:cNvSpPr>
+            <a:spLocks noGrp="1" noRot="1" noChangeAspect="1"/>
+          </p:cNvSpPr>
+          <p:nvPr>
+            <p:ph type="sldImg"/>
+          </p:nvPr>
+        </p:nvSpPr>
+        <p:spPr/>
+      </p:sp>
+      <p:sp>
+        <p:nvSpPr>
+          <p:cNvPr id="3" name="Notes Placeholder 2"/>
+          <p:cNvSpPr>
+            <a:spLocks noGrp="1"/>
+          </p:cNvSpPr>
+          <p:nvPr>
+            <p:ph type="body" idx="1"/>
+          </p:nvPr>
+        </p:nvSpPr>
+        <p:spPr/>
+        <p:txBody>
+          <a:bodyPr/>
+          <a:lstStyle/>
+          <a:p>
+            <a:r>
+              <a:rPr lang="en-US" dirty="0"/>
+              <a:t>Verification: each entry's title, authors, year and venue were checked against a publisher, library or official project page while building this deck. DOIs are given only where a page showed one. Items [1] and [5] show venue, volume and pages but no DOI, because none was confirmed. [7] has a stable official page but no DOI listed there. [8] is the CGO 2021 paper listed on Google Research's publication page; no DOI was confirmed. [10] is an arXiv preprint (not peer reviewed). A Halpern and Pearl structural-model causality paper was considered for the counterfactual theme and dropped because its journal venue could not be verified. Recent sources (2022 to 2024) are [6] (2022) and [10] (2023).</a:t>
+            </a:r>
+            <a:endParaRPr lang="en-US" dirty="0"/>
+          </a:p>
+        </p:txBody>
+      </p:sp>
+      <p:sp>
+        <p:nvSpPr>
+          <p:cNvPr id="4" name="Slide Number Placeholder 3"/>
+          <p:cNvSpPr>
+            <a:spLocks noGrp="1"/>
+          </p:cNvSpPr>
+          <p:nvPr>
+            <p:ph type="sldNum" sz="quarter" idx="10"/>
+          </p:nvPr>
+        </p:nvSpPr>
+        <p:spPr/>
+        <p:txBody>
+          <a:bodyPr/>
+          <a:lstStyle/>
+          <a:p>
+            <a:fld id="{F7021451-1387-4CA6-816F-3879F97B5CBC}" type="slidenum">
+              <a:rPr lang="en-US"/>
+              <a:t>22</a:t>
             </a:fld>
             <a:endParaRPr lang="en-US"/>
           </a:p>
@@ -17883,8 +17973,8 @@
         </p:nvSpPr>
         <p:spPr>
           <a:xfrm>
-            <a:off x="731520" y="4846320"/>
-            <a:ext cx="5486400" cy="822960"/>
+            <a:off x="731520" y="5257800"/>
+            <a:ext cx="5486400" cy="914400"/>
           </a:xfrm>
           <a:prstGeom prst="rect">
             <a:avLst/>
@@ -17916,58 +18006,7 @@
       </p:sp>
       <p:sp>
         <p:nvSpPr>
-          <p:cNvPr id="17" name="text-529"/>
-          <p:cNvSpPr txBox="1"/>
-          <p:nvPr/>
-        </p:nvSpPr>
-        <p:spPr>
-          <a:xfrm>
-            <a:off x="731520" y="5760720"/>
-            <a:ext cx="6400800" cy="411480"/>
-          </a:xfrm>
-          <a:prstGeom prst="rect">
-            <a:avLst/>
-          </a:prstGeom>
-          <a:noFill/>
-          <a:ln/>
-        </p:spPr>
-        <p:txBody>
-          <a:bodyPr wrap="square" lIns="0" tIns="0" rIns="0" bIns="0" rtlCol="0" anchor="ctr"/>
-          <a:lstStyle/>
-          <a:p>
-            <a:pPr indent="0" marL="0">
-              <a:buNone/>
-            </a:pPr>
-            <a:r>
-              <a:rPr lang="en-US" sz="2000" b="1" u="sng" dirty="0">
-                <a:solidFill>
-                  <a:srgbClr val="22D3EE"/>
-                </a:solidFill>
-                <a:uFill>
-                  <a:solidFill>
-                    <a:srgbClr val="22D3EE"/>
-                  </a:solidFill>
-                </a:uFill>
-                <a:latin typeface="Inter" pitchFamily="34" charset="0"/>
-                <a:ea typeface="Inter" pitchFamily="34" charset="-122"/>
-                <a:cs typeface="Inter" pitchFamily="34" charset="-120"/>
-                <a:hlinkClick r:id="rId1" invalidUrl="" action="" tgtFrame="" tooltip="CAUSA source code" history="1" highlightClick="0" endSnd="0">
-                  <a:extLst>
-                    <a:ext uri="{A12FA001-AC4F-418D-AE19-62706E023703}">
-                      <ahyp:hlinkClr xmlns:ahyp="http://schemas.microsoft.com/office/drawing/2018/hyperlinkcolor" val="tx"/>
-                    </a:ext>
-                  </a:extLst>
-                </a:hlinkClick>
-              </a:rPr>
-              <a:t>github.com/ujvall/causa</a:t>
-            </a:r>
-            <a:endParaRPr lang="en-US" sz="2000" dirty="0"/>
-          </a:p>
-        </p:txBody>
-      </p:sp>
-      <p:sp>
-        <p:nvSpPr>
-          <p:cNvPr id="18" name="panel-530"/>
+          <p:cNvPr id="17" name="panel-529"/>
           <p:cNvSpPr/>
           <p:nvPr/>
         </p:nvSpPr>
@@ -17994,7 +18033,7 @@
       </p:sp>
       <p:sp>
         <p:nvSpPr>
-          <p:cNvPr id="19" name="arrow-531"/>
+          <p:cNvPr id="18" name="arrow-530"/>
           <p:cNvSpPr/>
           <p:nvPr/>
         </p:nvSpPr>
@@ -18018,7 +18057,7 @@
       </p:sp>
       <p:sp>
         <p:nvSpPr>
-          <p:cNvPr id="20" name="arrow-532"/>
+          <p:cNvPr id="19" name="arrow-531"/>
           <p:cNvSpPr/>
           <p:nvPr/>
         </p:nvSpPr>
@@ -18042,7 +18081,7 @@
       </p:sp>
       <p:sp>
         <p:nvSpPr>
-          <p:cNvPr id="21" name="node-533"/>
+          <p:cNvPr id="20" name="node-532"/>
           <p:cNvSpPr/>
           <p:nvPr/>
         </p:nvSpPr>
@@ -18069,7 +18108,7 @@
       </p:sp>
       <p:sp>
         <p:nvSpPr>
-          <p:cNvPr id="22" name="text-534"/>
+          <p:cNvPr id="21" name="text-533"/>
           <p:cNvSpPr txBox="1"/>
           <p:nvPr/>
         </p:nvSpPr>
@@ -18108,7 +18147,7 @@
       </p:sp>
       <p:sp>
         <p:nvSpPr>
-          <p:cNvPr id="23" name="node-535"/>
+          <p:cNvPr id="22" name="node-534"/>
           <p:cNvSpPr/>
           <p:nvPr/>
         </p:nvSpPr>
@@ -18135,7 +18174,7 @@
       </p:sp>
       <p:sp>
         <p:nvSpPr>
-          <p:cNvPr id="24" name="text-536"/>
+          <p:cNvPr id="23" name="text-535"/>
           <p:cNvSpPr txBox="1"/>
           <p:nvPr/>
         </p:nvSpPr>
@@ -18174,7 +18213,7 @@
       </p:sp>
       <p:sp>
         <p:nvSpPr>
-          <p:cNvPr id="25" name="node-537"/>
+          <p:cNvPr id="24" name="node-536"/>
           <p:cNvSpPr/>
           <p:nvPr/>
         </p:nvSpPr>
@@ -18201,7 +18240,7 @@
       </p:sp>
       <p:sp>
         <p:nvSpPr>
-          <p:cNvPr id="26" name="text-538"/>
+          <p:cNvPr id="25" name="text-537"/>
           <p:cNvSpPr txBox="1"/>
           <p:nvPr/>
         </p:nvSpPr>
@@ -18265,16 +18304,14 @@
       </p:grpSpPr>
       <p:sp>
         <p:nvSpPr>
-          <p:cNvPr id="2" name="Text 0"/>
-          <p:cNvSpPr/>
-          <p:nvPr>
-            <p:ph idx="100" type="title" hasCustomPrompt="1"/>
-          </p:nvPr>
-        </p:nvSpPr>
-        <p:spPr>
-          <a:xfrm>
-            <a:off x="548640" y="365760"/>
-            <a:ext cx="11091672" cy="685800"/>
+          <p:cNvPr id="3" name="text-538"/>
+          <p:cNvSpPr txBox="1"/>
+          <p:nvPr/>
+        </p:nvSpPr>
+        <p:spPr>
+          <a:xfrm>
+            <a:off x="731520" y="822960"/>
+            <a:ext cx="10058400" cy="914400"/>
           </a:xfrm>
           <a:prstGeom prst="rect">
             <a:avLst/>
@@ -18286,11 +18323,11 @@
           <a:bodyPr wrap="square" lIns="0" tIns="0" rIns="0" bIns="0" rtlCol="0" anchor="t"/>
           <a:lstStyle/>
           <a:p>
-            <a:pPr algn="l" indent="0" marL="0">
-              <a:buNone/>
-            </a:pPr>
-            <a:r>
-              <a:rPr lang="en-US" sz="2800" b="1" spc="-50" kern="0" dirty="0">
+            <a:pPr indent="0" marL="0">
+              <a:buNone/>
+            </a:pPr>
+            <a:r>
+              <a:rPr lang="en-US" sz="4400" b="1" spc="-100" kern="0" dirty="0">
                 <a:solidFill>
                   <a:srgbClr val="ECECEE"/>
                 </a:solidFill>
@@ -18298,48 +18335,60 @@
                 <a:ea typeface="Inter" pitchFamily="34" charset="-122"/>
                 <a:cs typeface="Inter" pitchFamily="34" charset="-120"/>
               </a:rPr>
-              <a:t>Appendix: references</a:t>
-            </a:r>
-            <a:endParaRPr lang="en-US" sz="2800" dirty="0"/>
-          </a:p>
-        </p:txBody>
-      </p:sp>
-      <p:sp>
-        <p:nvSpPr>
-          <p:cNvPr id="3" name="text-539"/>
-          <p:cNvSpPr txBox="1"/>
-          <p:nvPr/>
-        </p:nvSpPr>
-        <p:spPr>
-          <a:xfrm>
-            <a:off x="548640" y="6446520"/>
-            <a:ext cx="5486400" cy="274320"/>
-          </a:xfrm>
-          <a:prstGeom prst="rect">
-            <a:avLst/>
-          </a:prstGeom>
-          <a:noFill/>
-          <a:ln/>
-        </p:spPr>
-        <p:txBody>
-          <a:bodyPr wrap="square" lIns="0" tIns="0" rIns="0" bIns="0" rtlCol="0" anchor="t"/>
-          <a:lstStyle/>
-          <a:p>
-            <a:pPr indent="0" marL="0">
-              <a:buNone/>
-            </a:pPr>
-            <a:r>
-              <a:rPr lang="en-US" sz="1000" dirty="0">
-                <a:solidFill>
-                  <a:srgbClr val="7C7C84"/>
-                </a:solidFill>
+              <a:t>Source code</a:t>
+            </a:r>
+            <a:endParaRPr lang="en-US" sz="4400" dirty="0"/>
+          </a:p>
+        </p:txBody>
+      </p:sp>
+      <p:sp>
+        <p:nvSpPr>
+          <p:cNvPr id="4" name="text-539"/>
+          <p:cNvSpPr txBox="1"/>
+          <p:nvPr/>
+        </p:nvSpPr>
+        <p:spPr>
+          <a:xfrm>
+            <a:off x="731520" y="1828800"/>
+            <a:ext cx="7315200" cy="548640"/>
+          </a:xfrm>
+          <a:prstGeom prst="rect">
+            <a:avLst/>
+          </a:prstGeom>
+          <a:noFill/>
+          <a:ln/>
+        </p:spPr>
+        <p:txBody>
+          <a:bodyPr wrap="square" lIns="0" tIns="0" rIns="0" bIns="0" rtlCol="0" anchor="ctr"/>
+          <a:lstStyle/>
+          <a:p>
+            <a:pPr indent="0" marL="0">
+              <a:buNone/>
+            </a:pPr>
+            <a:r>
+              <a:rPr lang="en-US" sz="2800" b="1" u="sng" dirty="0">
+                <a:solidFill>
+                  <a:srgbClr val="22D3EE"/>
+                </a:solidFill>
+                <a:uFill>
+                  <a:solidFill>
+                    <a:srgbClr val="22D3EE"/>
+                  </a:solidFill>
+                </a:uFill>
                 <a:latin typeface="Inter" pitchFamily="34" charset="0"/>
                 <a:ea typeface="Inter" pitchFamily="34" charset="-122"/>
                 <a:cs typeface="Inter" pitchFamily="34" charset="-120"/>
-              </a:rPr>
-              <a:t>CAUSA   Closing</a:t>
-            </a:r>
-            <a:endParaRPr lang="en-US" sz="1000" dirty="0"/>
+                <a:hlinkClick r:id="rId1" invalidUrl="" action="" tgtFrame="" tooltip="CAUSA source code" history="1" highlightClick="0" endSnd="0">
+                  <a:extLst>
+                    <a:ext uri="{A12FA001-AC4F-418D-AE19-62706E023703}">
+                      <ahyp:hlinkClr xmlns:ahyp="http://schemas.microsoft.com/office/drawing/2018/hyperlinkcolor" val="tx"/>
+                    </a:ext>
+                  </a:extLst>
+                </a:hlinkClick>
+              </a:rPr>
+              <a:t>github.com/ujvall/causa</a:t>
+            </a:r>
+            <a:endParaRPr lang="en-US" sz="2800" dirty="0"/>
           </a:p>
         </p:txBody>
       </p:sp>
@@ -18351,12 +18400,12 @@
         </p:nvSpPr>
         <p:spPr>
           <a:xfrm>
-            <a:off x="548640" y="1280160"/>
-            <a:ext cx="5440680" cy="4892040"/>
+            <a:off x="731520" y="2834640"/>
+            <a:ext cx="7406640" cy="438912"/>
           </a:xfrm>
           <a:prstGeom prst="roundRect">
             <a:avLst>
-              <a:gd name="adj" fmla="val 1495"/>
+              <a:gd name="adj" fmla="val 16667"/>
             </a:avLst>
           </a:prstGeom>
           <a:solidFill>
@@ -18378,23 +18427,59 @@
         </p:nvSpPr>
         <p:spPr>
           <a:xfrm>
-            <a:off x="731520" y="1417320"/>
-            <a:ext cx="5120640" cy="4663440"/>
-          </a:xfrm>
-          <a:prstGeom prst="rect">
-            <a:avLst/>
-          </a:prstGeom>
-          <a:noFill/>
-          <a:ln/>
-        </p:spPr>
-        <p:txBody>
-          <a:bodyPr wrap="square" lIns="0" tIns="0" rIns="0" bIns="0" rtlCol="0" anchor="t"/>
-          <a:lstStyle/>
-          <a:p>
-            <a:pPr indent="0" marL="0">
-              <a:spcAft>
-                <a:spcPts val="900"/>
-              </a:spcAft>
+            <a:off x="914400" y="2834640"/>
+            <a:ext cx="1645920" cy="438912"/>
+          </a:xfrm>
+          <a:prstGeom prst="rect">
+            <a:avLst/>
+          </a:prstGeom>
+          <a:noFill/>
+          <a:ln/>
+        </p:spPr>
+        <p:txBody>
+          <a:bodyPr wrap="square" lIns="0" tIns="0" rIns="0" bIns="0" rtlCol="0" anchor="ctr"/>
+          <a:lstStyle/>
+          <a:p>
+            <a:pPr indent="0" marL="0">
+              <a:buNone/>
+            </a:pPr>
+            <a:r>
+              <a:rPr lang="en-US" sz="1400" b="1" dirty="0">
+                <a:solidFill>
+                  <a:srgbClr val="22D3EE"/>
+                </a:solidFill>
+                <a:latin typeface="Consolas" pitchFamily="34" charset="0"/>
+                <a:ea typeface="Consolas" pitchFamily="34" charset="-122"/>
+                <a:cs typeface="Consolas" pitchFamily="34" charset="-120"/>
+              </a:rPr>
+              <a:t>causa/</a:t>
+            </a:r>
+            <a:endParaRPr lang="en-US" sz="1400" dirty="0"/>
+          </a:p>
+        </p:txBody>
+      </p:sp>
+      <p:sp>
+        <p:nvSpPr>
+          <p:cNvPr id="7" name="text-542"/>
+          <p:cNvSpPr txBox="1"/>
+          <p:nvPr/>
+        </p:nvSpPr>
+        <p:spPr>
+          <a:xfrm>
+            <a:off x="2560320" y="2834640"/>
+            <a:ext cx="5486400" cy="438912"/>
+          </a:xfrm>
+          <a:prstGeom prst="rect">
+            <a:avLst/>
+          </a:prstGeom>
+          <a:noFill/>
+          <a:ln/>
+        </p:spPr>
+        <p:txBody>
+          <a:bodyPr wrap="square" lIns="0" tIns="0" rIns="0" bIns="0" rtlCol="0" anchor="ctr"/>
+          <a:lstStyle/>
+          <a:p>
+            <a:pPr indent="0" marL="0">
               <a:buNone/>
             </a:pPr>
             <a:r>
@@ -18406,106 +18491,26 @@
                 <a:ea typeface="Inter" pitchFamily="34" charset="-122"/>
                 <a:cs typeface="Inter" pitchFamily="34" charset="-120"/>
               </a:rPr>
-              <a:t>[1] M. Weiser, “Program Slicing,” IEEE Transactions on Software Engineering, vol. 10, no. 4, pp. 352–357, 1984.</a:t>
-            </a:r>
-            <a:endParaRPr lang="en-US" sz="1600" dirty="0"/>
-          </a:p>
-          <a:p>
-            <a:pPr indent="0" marL="0">
-              <a:spcAft>
-                <a:spcPts val="900"/>
-              </a:spcAft>
-              <a:buNone/>
-            </a:pPr>
-            <a:r>
-              <a:rPr lang="en-US" sz="1300" dirty="0">
-                <a:solidFill>
-                  <a:srgbClr val="ECECEE"/>
-                </a:solidFill>
-                <a:latin typeface="Inter" pitchFamily="34" charset="0"/>
-                <a:ea typeface="Inter" pitchFamily="34" charset="-122"/>
-                <a:cs typeface="Inter" pitchFamily="34" charset="-120"/>
-              </a:rPr>
-              <a:t>[2] J. Ferrante, K. J. Ottenstein, J. D. Warren, “The Program Dependence Graph and Its Use in Optimization,” ACM TOPLAS, vol. 9, no. 3, pp. 319–349, 1987. doi:10.1145/24039.24041</a:t>
-            </a:r>
-            <a:endParaRPr lang="en-US" sz="1600" dirty="0"/>
-          </a:p>
-          <a:p>
-            <a:pPr indent="0" marL="0">
-              <a:spcAft>
-                <a:spcPts val="900"/>
-              </a:spcAft>
-              <a:buNone/>
-            </a:pPr>
-            <a:r>
-              <a:rPr lang="en-US" sz="1300" dirty="0">
-                <a:solidFill>
-                  <a:srgbClr val="ECECEE"/>
-                </a:solidFill>
-                <a:latin typeface="Inter" pitchFamily="34" charset="0"/>
-                <a:ea typeface="Inter" pitchFamily="34" charset="-122"/>
-                <a:cs typeface="Inter" pitchFamily="34" charset="-120"/>
-              </a:rPr>
-              <a:t>[3] J. Cheney, L. Chiticariu, W.-C. Tan, “Provenance in Databases: Why, How, and Where,” Foundations and Trends in Databases, vol. 1, no. 4, pp. 379–474, 2009. doi:10.1561/1900000006</a:t>
-            </a:r>
-            <a:endParaRPr lang="en-US" sz="1600" dirty="0"/>
-          </a:p>
-          <a:p>
-            <a:pPr indent="0" marL="0">
-              <a:spcAft>
-                <a:spcPts val="900"/>
-              </a:spcAft>
-              <a:buNone/>
-            </a:pPr>
-            <a:r>
-              <a:rPr lang="en-US" sz="1300" dirty="0">
-                <a:solidFill>
-                  <a:srgbClr val="ECECEE"/>
-                </a:solidFill>
-                <a:latin typeface="Inter" pitchFamily="34" charset="0"/>
-                <a:ea typeface="Inter" pitchFamily="34" charset="-122"/>
-                <a:cs typeface="Inter" pitchFamily="34" charset="-120"/>
-              </a:rPr>
-              <a:t>[4] J. Cheney, A. Ahmed, U. A. Acar, “Provenance as dependency analysis,” Mathematical Structures in Computer Science, vol. 21, no. 6, pp. 1301–1337, 2011. doi:10.1017/S0960129511000211</a:t>
-            </a:r>
-            <a:endParaRPr lang="en-US" sz="1600" dirty="0"/>
-          </a:p>
-          <a:p>
-            <a:pPr indent="0" marL="0">
-              <a:spcAft>
-                <a:spcPts val="900"/>
-              </a:spcAft>
-              <a:buNone/>
-            </a:pPr>
-            <a:r>
-              <a:rPr lang="en-US" sz="1300" dirty="0">
-                <a:solidFill>
-                  <a:srgbClr val="ECECEE"/>
-                </a:solidFill>
-                <a:latin typeface="Inter" pitchFamily="34" charset="0"/>
-                <a:ea typeface="Inter" pitchFamily="34" charset="-122"/>
-                <a:cs typeface="Inter" pitchFamily="34" charset="-120"/>
-              </a:rPr>
-              <a:t>[5] A. J. Ko, B. A. Myers, “Designing the Whyline: A Debugging Interface for Asking Questions About Program Behavior,” CHI 2004, Vienna, pp. 151–158.</a:t>
-            </a:r>
-            <a:endParaRPr lang="en-US" sz="1600" dirty="0"/>
-          </a:p>
-        </p:txBody>
-      </p:sp>
-      <p:sp>
-        <p:nvSpPr>
-          <p:cNvPr id="7" name="card-542"/>
+              <a:t>compiler pipeline and C runtime</a:t>
+            </a:r>
+            <a:endParaRPr lang="en-US" sz="1300" dirty="0"/>
+          </a:p>
+        </p:txBody>
+      </p:sp>
+      <p:sp>
+        <p:nvSpPr>
+          <p:cNvPr id="8" name="card-543"/>
           <p:cNvSpPr/>
           <p:nvPr/>
         </p:nvSpPr>
         <p:spPr>
           <a:xfrm>
-            <a:off x="6199632" y="1280160"/>
-            <a:ext cx="5440680" cy="4892040"/>
+            <a:off x="731520" y="3364992"/>
+            <a:ext cx="7406640" cy="438912"/>
           </a:xfrm>
           <a:prstGeom prst="roundRect">
             <a:avLst>
-              <a:gd name="adj" fmla="val 1495"/>
+              <a:gd name="adj" fmla="val 16667"/>
             </a:avLst>
           </a:prstGeom>
           <a:solidFill>
@@ -18521,7 +18526,849 @@
       </p:sp>
       <p:sp>
         <p:nvSpPr>
-          <p:cNvPr id="8" name="text-543"/>
+          <p:cNvPr id="9" name="text-544"/>
+          <p:cNvSpPr txBox="1"/>
+          <p:nvPr/>
+        </p:nvSpPr>
+        <p:spPr>
+          <a:xfrm>
+            <a:off x="914400" y="3364992"/>
+            <a:ext cx="1645920" cy="438912"/>
+          </a:xfrm>
+          <a:prstGeom prst="rect">
+            <a:avLst/>
+          </a:prstGeom>
+          <a:noFill/>
+          <a:ln/>
+        </p:spPr>
+        <p:txBody>
+          <a:bodyPr wrap="square" lIns="0" tIns="0" rIns="0" bIns="0" rtlCol="0" anchor="ctr"/>
+          <a:lstStyle/>
+          <a:p>
+            <a:pPr indent="0" marL="0">
+              <a:buNone/>
+            </a:pPr>
+            <a:r>
+              <a:rPr lang="en-US" sz="1400" b="1" dirty="0">
+                <a:solidFill>
+                  <a:srgbClr val="22D3EE"/>
+                </a:solidFill>
+                <a:latin typeface="Consolas" pitchFamily="34" charset="0"/>
+                <a:ea typeface="Consolas" pitchFamily="34" charset="-122"/>
+                <a:cs typeface="Consolas" pitchFamily="34" charset="-120"/>
+              </a:rPr>
+              <a:t>studio/</a:t>
+            </a:r>
+            <a:endParaRPr lang="en-US" sz="1400" dirty="0"/>
+          </a:p>
+        </p:txBody>
+      </p:sp>
+      <p:sp>
+        <p:nvSpPr>
+          <p:cNvPr id="10" name="text-545"/>
+          <p:cNvSpPr txBox="1"/>
+          <p:nvPr/>
+        </p:nvSpPr>
+        <p:spPr>
+          <a:xfrm>
+            <a:off x="2560320" y="3364992"/>
+            <a:ext cx="5486400" cy="438912"/>
+          </a:xfrm>
+          <a:prstGeom prst="rect">
+            <a:avLst/>
+          </a:prstGeom>
+          <a:noFill/>
+          <a:ln/>
+        </p:spPr>
+        <p:txBody>
+          <a:bodyPr wrap="square" lIns="0" tIns="0" rIns="0" bIns="0" rtlCol="0" anchor="ctr"/>
+          <a:lstStyle/>
+          <a:p>
+            <a:pPr indent="0" marL="0">
+              <a:buNone/>
+            </a:pPr>
+            <a:r>
+              <a:rPr lang="en-US" sz="1300" dirty="0">
+                <a:solidFill>
+                  <a:srgbClr val="ECECEE"/>
+                </a:solidFill>
+                <a:latin typeface="Inter" pitchFamily="34" charset="0"/>
+                <a:ea typeface="Inter" pitchFamily="34" charset="-122"/>
+                <a:cs typeface="Inter" pitchFamily="34" charset="-120"/>
+              </a:rPr>
+              <a:t>CAUSA Studio desktop application</a:t>
+            </a:r>
+            <a:endParaRPr lang="en-US" sz="1300" dirty="0"/>
+          </a:p>
+        </p:txBody>
+      </p:sp>
+      <p:sp>
+        <p:nvSpPr>
+          <p:cNvPr id="11" name="card-546"/>
+          <p:cNvSpPr/>
+          <p:nvPr/>
+        </p:nvSpPr>
+        <p:spPr>
+          <a:xfrm>
+            <a:off x="731520" y="3895344"/>
+            <a:ext cx="7406640" cy="438912"/>
+          </a:xfrm>
+          <a:prstGeom prst="roundRect">
+            <a:avLst>
+              <a:gd name="adj" fmla="val 16667"/>
+            </a:avLst>
+          </a:prstGeom>
+          <a:solidFill>
+            <a:srgbClr val="121214"/>
+          </a:solidFill>
+          <a:ln w="12700">
+            <a:solidFill>
+              <a:srgbClr val="2B2B31"/>
+            </a:solidFill>
+            <a:prstDash val="solid"/>
+          </a:ln>
+        </p:spPr>
+      </p:sp>
+      <p:sp>
+        <p:nvSpPr>
+          <p:cNvPr id="12" name="text-547"/>
+          <p:cNvSpPr txBox="1"/>
+          <p:nvPr/>
+        </p:nvSpPr>
+        <p:spPr>
+          <a:xfrm>
+            <a:off x="914400" y="3895344"/>
+            <a:ext cx="1645920" cy="438912"/>
+          </a:xfrm>
+          <a:prstGeom prst="rect">
+            <a:avLst/>
+          </a:prstGeom>
+          <a:noFill/>
+          <a:ln/>
+        </p:spPr>
+        <p:txBody>
+          <a:bodyPr wrap="square" lIns="0" tIns="0" rIns="0" bIns="0" rtlCol="0" anchor="ctr"/>
+          <a:lstStyle/>
+          <a:p>
+            <a:pPr indent="0" marL="0">
+              <a:buNone/>
+            </a:pPr>
+            <a:r>
+              <a:rPr lang="en-US" sz="1400" b="1" dirty="0">
+                <a:solidFill>
+                  <a:srgbClr val="22D3EE"/>
+                </a:solidFill>
+                <a:latin typeface="Consolas" pitchFamily="34" charset="0"/>
+                <a:ea typeface="Consolas" pitchFamily="34" charset="-122"/>
+                <a:cs typeface="Consolas" pitchFamily="34" charset="-120"/>
+              </a:rPr>
+              <a:t>examples/</a:t>
+            </a:r>
+            <a:endParaRPr lang="en-US" sz="1400" dirty="0"/>
+          </a:p>
+        </p:txBody>
+      </p:sp>
+      <p:sp>
+        <p:nvSpPr>
+          <p:cNvPr id="13" name="text-548"/>
+          <p:cNvSpPr txBox="1"/>
+          <p:nvPr/>
+        </p:nvSpPr>
+        <p:spPr>
+          <a:xfrm>
+            <a:off x="2560320" y="3895344"/>
+            <a:ext cx="5486400" cy="438912"/>
+          </a:xfrm>
+          <a:prstGeom prst="rect">
+            <a:avLst/>
+          </a:prstGeom>
+          <a:noFill/>
+          <a:ln/>
+        </p:spPr>
+        <p:txBody>
+          <a:bodyPr wrap="square" lIns="0" tIns="0" rIns="0" bIns="0" rtlCol="0" anchor="ctr"/>
+          <a:lstStyle/>
+          <a:p>
+            <a:pPr indent="0" marL="0">
+              <a:buNone/>
+            </a:pPr>
+            <a:r>
+              <a:rPr lang="en-US" sz="1300" dirty="0">
+                <a:solidFill>
+                  <a:srgbClr val="ECECEE"/>
+                </a:solidFill>
+                <a:latin typeface="Inter" pitchFamily="34" charset="0"/>
+                <a:ea typeface="Inter" pitchFamily="34" charset="-122"/>
+                <a:cs typeface="Inter" pitchFamily="34" charset="-120"/>
+              </a:rPr>
+              <a:t>pricing.cau and other sample programs</a:t>
+            </a:r>
+            <a:endParaRPr lang="en-US" sz="1300" dirty="0"/>
+          </a:p>
+        </p:txBody>
+      </p:sp>
+      <p:sp>
+        <p:nvSpPr>
+          <p:cNvPr id="14" name="card-549"/>
+          <p:cNvSpPr/>
+          <p:nvPr/>
+        </p:nvSpPr>
+        <p:spPr>
+          <a:xfrm>
+            <a:off x="731520" y="4425696"/>
+            <a:ext cx="7406640" cy="438912"/>
+          </a:xfrm>
+          <a:prstGeom prst="roundRect">
+            <a:avLst>
+              <a:gd name="adj" fmla="val 16667"/>
+            </a:avLst>
+          </a:prstGeom>
+          <a:solidFill>
+            <a:srgbClr val="121214"/>
+          </a:solidFill>
+          <a:ln w="12700">
+            <a:solidFill>
+              <a:srgbClr val="2B2B31"/>
+            </a:solidFill>
+            <a:prstDash val="solid"/>
+          </a:ln>
+        </p:spPr>
+      </p:sp>
+      <p:sp>
+        <p:nvSpPr>
+          <p:cNvPr id="15" name="text-550"/>
+          <p:cNvSpPr txBox="1"/>
+          <p:nvPr/>
+        </p:nvSpPr>
+        <p:spPr>
+          <a:xfrm>
+            <a:off x="914400" y="4425696"/>
+            <a:ext cx="1645920" cy="438912"/>
+          </a:xfrm>
+          <a:prstGeom prst="rect">
+            <a:avLst/>
+          </a:prstGeom>
+          <a:noFill/>
+          <a:ln/>
+        </p:spPr>
+        <p:txBody>
+          <a:bodyPr wrap="square" lIns="0" tIns="0" rIns="0" bIns="0" rtlCol="0" anchor="ctr"/>
+          <a:lstStyle/>
+          <a:p>
+            <a:pPr indent="0" marL="0">
+              <a:buNone/>
+            </a:pPr>
+            <a:r>
+              <a:rPr lang="en-US" sz="1400" b="1" dirty="0">
+                <a:solidFill>
+                  <a:srgbClr val="22D3EE"/>
+                </a:solidFill>
+                <a:latin typeface="Consolas" pitchFamily="34" charset="0"/>
+                <a:ea typeface="Consolas" pitchFamily="34" charset="-122"/>
+                <a:cs typeface="Consolas" pitchFamily="34" charset="-120"/>
+              </a:rPr>
+              <a:t>tests/</a:t>
+            </a:r>
+            <a:endParaRPr lang="en-US" sz="1400" dirty="0"/>
+          </a:p>
+        </p:txBody>
+      </p:sp>
+      <p:sp>
+        <p:nvSpPr>
+          <p:cNvPr id="16" name="text-551"/>
+          <p:cNvSpPr txBox="1"/>
+          <p:nvPr/>
+        </p:nvSpPr>
+        <p:spPr>
+          <a:xfrm>
+            <a:off x="2560320" y="4425696"/>
+            <a:ext cx="5486400" cy="438912"/>
+          </a:xfrm>
+          <a:prstGeom prst="rect">
+            <a:avLst/>
+          </a:prstGeom>
+          <a:noFill/>
+          <a:ln/>
+        </p:spPr>
+        <p:txBody>
+          <a:bodyPr wrap="square" lIns="0" tIns="0" rIns="0" bIns="0" rtlCol="0" anchor="ctr"/>
+          <a:lstStyle/>
+          <a:p>
+            <a:pPr indent="0" marL="0">
+              <a:buNone/>
+            </a:pPr>
+            <a:r>
+              <a:rPr lang="en-US" sz="1300" dirty="0">
+                <a:solidFill>
+                  <a:srgbClr val="ECECEE"/>
+                </a:solidFill>
+                <a:latin typeface="Inter" pitchFamily="34" charset="0"/>
+                <a:ea typeface="Inter" pitchFamily="34" charset="-122"/>
+                <a:cs typeface="Inter" pitchFamily="34" charset="-120"/>
+              </a:rPr>
+              <a:t>automated test suite</a:t>
+            </a:r>
+            <a:endParaRPr lang="en-US" sz="1300" dirty="0"/>
+          </a:p>
+        </p:txBody>
+      </p:sp>
+      <p:sp>
+        <p:nvSpPr>
+          <p:cNvPr id="17" name="card-552"/>
+          <p:cNvSpPr/>
+          <p:nvPr/>
+        </p:nvSpPr>
+        <p:spPr>
+          <a:xfrm>
+            <a:off x="731520" y="4956048"/>
+            <a:ext cx="7406640" cy="438912"/>
+          </a:xfrm>
+          <a:prstGeom prst="roundRect">
+            <a:avLst>
+              <a:gd name="adj" fmla="val 16667"/>
+            </a:avLst>
+          </a:prstGeom>
+          <a:solidFill>
+            <a:srgbClr val="121214"/>
+          </a:solidFill>
+          <a:ln w="12700">
+            <a:solidFill>
+              <a:srgbClr val="2B2B31"/>
+            </a:solidFill>
+            <a:prstDash val="solid"/>
+          </a:ln>
+        </p:spPr>
+      </p:sp>
+      <p:sp>
+        <p:nvSpPr>
+          <p:cNvPr id="18" name="text-553"/>
+          <p:cNvSpPr txBox="1"/>
+          <p:nvPr/>
+        </p:nvSpPr>
+        <p:spPr>
+          <a:xfrm>
+            <a:off x="914400" y="4956048"/>
+            <a:ext cx="1645920" cy="438912"/>
+          </a:xfrm>
+          <a:prstGeom prst="rect">
+            <a:avLst/>
+          </a:prstGeom>
+          <a:noFill/>
+          <a:ln/>
+        </p:spPr>
+        <p:txBody>
+          <a:bodyPr wrap="square" lIns="0" tIns="0" rIns="0" bIns="0" rtlCol="0" anchor="ctr"/>
+          <a:lstStyle/>
+          <a:p>
+            <a:pPr indent="0" marL="0">
+              <a:buNone/>
+            </a:pPr>
+            <a:r>
+              <a:rPr lang="en-US" sz="1400" b="1" dirty="0">
+                <a:solidFill>
+                  <a:srgbClr val="22D3EE"/>
+                </a:solidFill>
+                <a:latin typeface="Consolas" pitchFamily="34" charset="0"/>
+                <a:ea typeface="Consolas" pitchFamily="34" charset="-122"/>
+                <a:cs typeface="Consolas" pitchFamily="34" charset="-120"/>
+              </a:rPr>
+              <a:t>benchmarks/</a:t>
+            </a:r>
+            <a:endParaRPr lang="en-US" sz="1400" dirty="0"/>
+          </a:p>
+        </p:txBody>
+      </p:sp>
+      <p:sp>
+        <p:nvSpPr>
+          <p:cNvPr id="19" name="text-554"/>
+          <p:cNvSpPr txBox="1"/>
+          <p:nvPr/>
+        </p:nvSpPr>
+        <p:spPr>
+          <a:xfrm>
+            <a:off x="2560320" y="4956048"/>
+            <a:ext cx="5486400" cy="438912"/>
+          </a:xfrm>
+          <a:prstGeom prst="rect">
+            <a:avLst/>
+          </a:prstGeom>
+          <a:noFill/>
+          <a:ln/>
+        </p:spPr>
+        <p:txBody>
+          <a:bodyPr wrap="square" lIns="0" tIns="0" rIns="0" bIns="0" rtlCol="0" anchor="ctr"/>
+          <a:lstStyle/>
+          <a:p>
+            <a:pPr indent="0" marL="0">
+              <a:buNone/>
+            </a:pPr>
+            <a:r>
+              <a:rPr lang="en-US" sz="1300" dirty="0">
+                <a:solidFill>
+                  <a:srgbClr val="ECECEE"/>
+                </a:solidFill>
+                <a:latin typeface="Inter" pitchFamily="34" charset="0"/>
+                <a:ea typeface="Inter" pitchFamily="34" charset="-122"/>
+                <a:cs typeface="Inter" pitchFamily="34" charset="-120"/>
+              </a:rPr>
+              <a:t>benchmark script behind the performance slide</a:t>
+            </a:r>
+            <a:endParaRPr lang="en-US" sz="1300" dirty="0"/>
+          </a:p>
+        </p:txBody>
+      </p:sp>
+      <p:sp>
+        <p:nvSpPr>
+          <p:cNvPr id="20" name="card-555"/>
+          <p:cNvSpPr/>
+          <p:nvPr/>
+        </p:nvSpPr>
+        <p:spPr>
+          <a:xfrm>
+            <a:off x="731520" y="5486400"/>
+            <a:ext cx="7406640" cy="438912"/>
+          </a:xfrm>
+          <a:prstGeom prst="roundRect">
+            <a:avLst>
+              <a:gd name="adj" fmla="val 16667"/>
+            </a:avLst>
+          </a:prstGeom>
+          <a:solidFill>
+            <a:srgbClr val="121214"/>
+          </a:solidFill>
+          <a:ln w="12700">
+            <a:solidFill>
+              <a:srgbClr val="2B2B31"/>
+            </a:solidFill>
+            <a:prstDash val="solid"/>
+          </a:ln>
+        </p:spPr>
+      </p:sp>
+      <p:sp>
+        <p:nvSpPr>
+          <p:cNvPr id="21" name="text-556"/>
+          <p:cNvSpPr txBox="1"/>
+          <p:nvPr/>
+        </p:nvSpPr>
+        <p:spPr>
+          <a:xfrm>
+            <a:off x="914400" y="5486400"/>
+            <a:ext cx="1645920" cy="438912"/>
+          </a:xfrm>
+          <a:prstGeom prst="rect">
+            <a:avLst/>
+          </a:prstGeom>
+          <a:noFill/>
+          <a:ln/>
+        </p:spPr>
+        <p:txBody>
+          <a:bodyPr wrap="square" lIns="0" tIns="0" rIns="0" bIns="0" rtlCol="0" anchor="ctr"/>
+          <a:lstStyle/>
+          <a:p>
+            <a:pPr indent="0" marL="0">
+              <a:buNone/>
+            </a:pPr>
+            <a:r>
+              <a:rPr lang="en-US" sz="1400" b="1" dirty="0">
+                <a:solidFill>
+                  <a:srgbClr val="22D3EE"/>
+                </a:solidFill>
+                <a:latin typeface="Consolas" pitchFamily="34" charset="0"/>
+                <a:ea typeface="Consolas" pitchFamily="34" charset="-122"/>
+                <a:cs typeface="Consolas" pitchFamily="34" charset="-120"/>
+              </a:rPr>
+              <a:t>docs/</a:t>
+            </a:r>
+            <a:endParaRPr lang="en-US" sz="1400" dirty="0"/>
+          </a:p>
+        </p:txBody>
+      </p:sp>
+      <p:sp>
+        <p:nvSpPr>
+          <p:cNvPr id="22" name="text-557"/>
+          <p:cNvSpPr txBox="1"/>
+          <p:nvPr/>
+        </p:nvSpPr>
+        <p:spPr>
+          <a:xfrm>
+            <a:off x="2560320" y="5486400"/>
+            <a:ext cx="5486400" cy="438912"/>
+          </a:xfrm>
+          <a:prstGeom prst="rect">
+            <a:avLst/>
+          </a:prstGeom>
+          <a:noFill/>
+          <a:ln/>
+        </p:spPr>
+        <p:txBody>
+          <a:bodyPr wrap="square" lIns="0" tIns="0" rIns="0" bIns="0" rtlCol="0" anchor="ctr"/>
+          <a:lstStyle/>
+          <a:p>
+            <a:pPr indent="0" marL="0">
+              <a:buNone/>
+            </a:pPr>
+            <a:r>
+              <a:rPr lang="en-US" sz="1300" dirty="0">
+                <a:solidFill>
+                  <a:srgbClr val="ECECEE"/>
+                </a:solidFill>
+                <a:latin typeface="Inter" pitchFamily="34" charset="0"/>
+                <a:ea typeface="Inter" pitchFamily="34" charset="-122"/>
+                <a:cs typeface="Inter" pitchFamily="34" charset="-120"/>
+              </a:rPr>
+              <a:t>language specification, architecture, demonstration, evaluation</a:t>
+            </a:r>
+            <a:endParaRPr lang="en-US" sz="1300" dirty="0"/>
+          </a:p>
+        </p:txBody>
+      </p:sp>
+      <p:pic>
+        <p:nvPicPr>
+          <p:cNvPr id="23" name="Image 0" descr="QR code linking to github.com/ujvall/causa">    </p:cNvPr>
+          <p:cNvPicPr>
+            <a:picLocks noChangeAspect="1"/>
+          </p:cNvPicPr>
+          <p:nvPr/>
+        </p:nvPicPr>
+        <p:blipFill>
+          <a:blip r:embed="rId2"/>
+          <a:stretch>
+            <a:fillRect/>
+          </a:stretch>
+        </p:blipFill>
+        <p:spPr>
+          <a:xfrm>
+            <a:off x="8869680" y="2834640"/>
+            <a:ext cx="2743200" cy="2743200"/>
+          </a:xfrm>
+          <a:prstGeom prst="rect">
+            <a:avLst/>
+          </a:prstGeom>
+        </p:spPr>
+      </p:pic>
+      <p:sp>
+        <p:nvSpPr>
+          <p:cNvPr id="24" name="text-558"/>
+          <p:cNvSpPr txBox="1"/>
+          <p:nvPr/>
+        </p:nvSpPr>
+        <p:spPr>
+          <a:xfrm>
+            <a:off x="8869680" y="5715000"/>
+            <a:ext cx="2743200" cy="365760"/>
+          </a:xfrm>
+          <a:prstGeom prst="rect">
+            <a:avLst/>
+          </a:prstGeom>
+          <a:noFill/>
+          <a:ln/>
+        </p:spPr>
+        <p:txBody>
+          <a:bodyPr wrap="square" lIns="0" tIns="0" rIns="0" bIns="0" rtlCol="0" anchor="t"/>
+          <a:lstStyle/>
+          <a:p>
+            <a:pPr algn="ctr" indent="0" marL="0">
+              <a:buNone/>
+            </a:pPr>
+            <a:r>
+              <a:rPr lang="en-US" sz="1300" dirty="0">
+                <a:solidFill>
+                  <a:srgbClr val="8E8E96"/>
+                </a:solidFill>
+                <a:latin typeface="Inter" pitchFamily="34" charset="0"/>
+                <a:ea typeface="Inter" pitchFamily="34" charset="-122"/>
+                <a:cs typeface="Inter" pitchFamily="34" charset="-120"/>
+              </a:rPr>
+              <a:t>Scan to open the repository</a:t>
+            </a:r>
+            <a:endParaRPr lang="en-US" sz="1300" dirty="0"/>
+          </a:p>
+        </p:txBody>
+      </p:sp>
+    </p:spTree>
+  </p:cSld>
+  <p:clrMapOvr>
+    <a:masterClrMapping/>
+  </p:clrMapOvr>
+</p:sld>
+</file>
+
+<file path=ppt/slides/slide22.xml><?xml version="1.0" encoding="utf-8"?>
+<p:sld xmlns:a="http://schemas.openxmlformats.org/drawingml/2006/main" xmlns:r="http://schemas.openxmlformats.org/officeDocument/2006/relationships" xmlns:p="http://schemas.openxmlformats.org/presentationml/2006/main">
+  <p:cSld name="Slide 22">
+    <p:spTree>
+      <p:nvGrpSpPr>
+        <p:cNvPr id="1" name=""/>
+        <p:cNvGrpSpPr/>
+        <p:nvPr/>
+      </p:nvGrpSpPr>
+      <p:grpSpPr>
+        <a:xfrm>
+          <a:off x="0" y="0"/>
+          <a:ext cx="0" cy="0"/>
+          <a:chOff x="0" y="0"/>
+          <a:chExt cx="0" cy="0"/>
+        </a:xfrm>
+      </p:grpSpPr>
+      <p:sp>
+        <p:nvSpPr>
+          <p:cNvPr id="2" name="Text 0"/>
+          <p:cNvSpPr/>
+          <p:nvPr>
+            <p:ph idx="100" type="title" hasCustomPrompt="1"/>
+          </p:nvPr>
+        </p:nvSpPr>
+        <p:spPr>
+          <a:xfrm>
+            <a:off x="548640" y="365760"/>
+            <a:ext cx="11091672" cy="685800"/>
+          </a:xfrm>
+          <a:prstGeom prst="rect">
+            <a:avLst/>
+          </a:prstGeom>
+          <a:noFill/>
+          <a:ln/>
+        </p:spPr>
+        <p:txBody>
+          <a:bodyPr wrap="square" lIns="0" tIns="0" rIns="0" bIns="0" rtlCol="0" anchor="t"/>
+          <a:lstStyle/>
+          <a:p>
+            <a:pPr algn="l" indent="0" marL="0">
+              <a:buNone/>
+            </a:pPr>
+            <a:r>
+              <a:rPr lang="en-US" sz="2800" b="1" spc="-50" kern="0" dirty="0">
+                <a:solidFill>
+                  <a:srgbClr val="ECECEE"/>
+                </a:solidFill>
+                <a:latin typeface="Inter" pitchFamily="34" charset="0"/>
+                <a:ea typeface="Inter" pitchFamily="34" charset="-122"/>
+                <a:cs typeface="Inter" pitchFamily="34" charset="-120"/>
+              </a:rPr>
+              <a:t>Appendix: references</a:t>
+            </a:r>
+            <a:endParaRPr lang="en-US" sz="2800" dirty="0"/>
+          </a:p>
+        </p:txBody>
+      </p:sp>
+      <p:sp>
+        <p:nvSpPr>
+          <p:cNvPr id="3" name="text-559"/>
+          <p:cNvSpPr txBox="1"/>
+          <p:nvPr/>
+        </p:nvSpPr>
+        <p:spPr>
+          <a:xfrm>
+            <a:off x="548640" y="6446520"/>
+            <a:ext cx="5486400" cy="274320"/>
+          </a:xfrm>
+          <a:prstGeom prst="rect">
+            <a:avLst/>
+          </a:prstGeom>
+          <a:noFill/>
+          <a:ln/>
+        </p:spPr>
+        <p:txBody>
+          <a:bodyPr wrap="square" lIns="0" tIns="0" rIns="0" bIns="0" rtlCol="0" anchor="t"/>
+          <a:lstStyle/>
+          <a:p>
+            <a:pPr indent="0" marL="0">
+              <a:buNone/>
+            </a:pPr>
+            <a:r>
+              <a:rPr lang="en-US" sz="1000" dirty="0">
+                <a:solidFill>
+                  <a:srgbClr val="7C7C84"/>
+                </a:solidFill>
+                <a:latin typeface="Inter" pitchFamily="34" charset="0"/>
+                <a:ea typeface="Inter" pitchFamily="34" charset="-122"/>
+                <a:cs typeface="Inter" pitchFamily="34" charset="-120"/>
+              </a:rPr>
+              <a:t>CAUSA   Closing</a:t>
+            </a:r>
+            <a:endParaRPr lang="en-US" sz="1000" dirty="0"/>
+          </a:p>
+        </p:txBody>
+      </p:sp>
+      <p:sp>
+        <p:nvSpPr>
+          <p:cNvPr id="5" name="card-560"/>
+          <p:cNvSpPr/>
+          <p:nvPr/>
+        </p:nvSpPr>
+        <p:spPr>
+          <a:xfrm>
+            <a:off x="548640" y="1280160"/>
+            <a:ext cx="5440680" cy="4892040"/>
+          </a:xfrm>
+          <a:prstGeom prst="roundRect">
+            <a:avLst>
+              <a:gd name="adj" fmla="val 1495"/>
+            </a:avLst>
+          </a:prstGeom>
+          <a:solidFill>
+            <a:srgbClr val="121214"/>
+          </a:solidFill>
+          <a:ln w="12700">
+            <a:solidFill>
+              <a:srgbClr val="2B2B31"/>
+            </a:solidFill>
+            <a:prstDash val="solid"/>
+          </a:ln>
+        </p:spPr>
+      </p:sp>
+      <p:sp>
+        <p:nvSpPr>
+          <p:cNvPr id="6" name="text-561"/>
+          <p:cNvSpPr txBox="1"/>
+          <p:nvPr/>
+        </p:nvSpPr>
+        <p:spPr>
+          <a:xfrm>
+            <a:off x="731520" y="1417320"/>
+            <a:ext cx="5120640" cy="4663440"/>
+          </a:xfrm>
+          <a:prstGeom prst="rect">
+            <a:avLst/>
+          </a:prstGeom>
+          <a:noFill/>
+          <a:ln/>
+        </p:spPr>
+        <p:txBody>
+          <a:bodyPr wrap="square" lIns="0" tIns="0" rIns="0" bIns="0" rtlCol="0" anchor="t"/>
+          <a:lstStyle/>
+          <a:p>
+            <a:pPr indent="0" marL="0">
+              <a:spcAft>
+                <a:spcPts val="900"/>
+              </a:spcAft>
+              <a:buNone/>
+            </a:pPr>
+            <a:r>
+              <a:rPr lang="en-US" sz="1300" dirty="0">
+                <a:solidFill>
+                  <a:srgbClr val="ECECEE"/>
+                </a:solidFill>
+                <a:latin typeface="Inter" pitchFamily="34" charset="0"/>
+                <a:ea typeface="Inter" pitchFamily="34" charset="-122"/>
+                <a:cs typeface="Inter" pitchFamily="34" charset="-120"/>
+              </a:rPr>
+              <a:t>[1] M. Weiser, “Program Slicing,” IEEE Transactions on Software Engineering, vol. 10, no. 4, pp. 352–357, 1984.</a:t>
+            </a:r>
+            <a:endParaRPr lang="en-US" sz="1600" dirty="0"/>
+          </a:p>
+          <a:p>
+            <a:pPr indent="0" marL="0">
+              <a:spcAft>
+                <a:spcPts val="900"/>
+              </a:spcAft>
+              <a:buNone/>
+            </a:pPr>
+            <a:r>
+              <a:rPr lang="en-US" sz="1300" dirty="0">
+                <a:solidFill>
+                  <a:srgbClr val="ECECEE"/>
+                </a:solidFill>
+                <a:latin typeface="Inter" pitchFamily="34" charset="0"/>
+                <a:ea typeface="Inter" pitchFamily="34" charset="-122"/>
+                <a:cs typeface="Inter" pitchFamily="34" charset="-120"/>
+              </a:rPr>
+              <a:t>[2] J. Ferrante, K. J. Ottenstein, J. D. Warren, “The Program Dependence Graph and Its Use in Optimization,” ACM TOPLAS, vol. 9, no. 3, pp. 319–349, 1987. doi:10.1145/24039.24041</a:t>
+            </a:r>
+            <a:endParaRPr lang="en-US" sz="1600" dirty="0"/>
+          </a:p>
+          <a:p>
+            <a:pPr indent="0" marL="0">
+              <a:spcAft>
+                <a:spcPts val="900"/>
+              </a:spcAft>
+              <a:buNone/>
+            </a:pPr>
+            <a:r>
+              <a:rPr lang="en-US" sz="1300" dirty="0">
+                <a:solidFill>
+                  <a:srgbClr val="ECECEE"/>
+                </a:solidFill>
+                <a:latin typeface="Inter" pitchFamily="34" charset="0"/>
+                <a:ea typeface="Inter" pitchFamily="34" charset="-122"/>
+                <a:cs typeface="Inter" pitchFamily="34" charset="-120"/>
+              </a:rPr>
+              <a:t>[3] J. Cheney, L. Chiticariu, W.-C. Tan, “Provenance in Databases: Why, How, and Where,” Foundations and Trends in Databases, vol. 1, no. 4, pp. 379–474, 2009. doi:10.1561/1900000006</a:t>
+            </a:r>
+            <a:endParaRPr lang="en-US" sz="1600" dirty="0"/>
+          </a:p>
+          <a:p>
+            <a:pPr indent="0" marL="0">
+              <a:spcAft>
+                <a:spcPts val="900"/>
+              </a:spcAft>
+              <a:buNone/>
+            </a:pPr>
+            <a:r>
+              <a:rPr lang="en-US" sz="1300" dirty="0">
+                <a:solidFill>
+                  <a:srgbClr val="ECECEE"/>
+                </a:solidFill>
+                <a:latin typeface="Inter" pitchFamily="34" charset="0"/>
+                <a:ea typeface="Inter" pitchFamily="34" charset="-122"/>
+                <a:cs typeface="Inter" pitchFamily="34" charset="-120"/>
+              </a:rPr>
+              <a:t>[4] J. Cheney, A. Ahmed, U. A. Acar, “Provenance as dependency analysis,” Mathematical Structures in Computer Science, vol. 21, no. 6, pp. 1301–1337, 2011. doi:10.1017/S0960129511000211</a:t>
+            </a:r>
+            <a:endParaRPr lang="en-US" sz="1600" dirty="0"/>
+          </a:p>
+          <a:p>
+            <a:pPr indent="0" marL="0">
+              <a:spcAft>
+                <a:spcPts val="900"/>
+              </a:spcAft>
+              <a:buNone/>
+            </a:pPr>
+            <a:r>
+              <a:rPr lang="en-US" sz="1300" dirty="0">
+                <a:solidFill>
+                  <a:srgbClr val="ECECEE"/>
+                </a:solidFill>
+                <a:latin typeface="Inter" pitchFamily="34" charset="0"/>
+                <a:ea typeface="Inter" pitchFamily="34" charset="-122"/>
+                <a:cs typeface="Inter" pitchFamily="34" charset="-120"/>
+              </a:rPr>
+              <a:t>[5] A. J. Ko, B. A. Myers, “Designing the Whyline: A Debugging Interface for Asking Questions About Program Behavior,” CHI 2004, Vienna, pp. 151–158.</a:t>
+            </a:r>
+            <a:endParaRPr lang="en-US" sz="1600" dirty="0"/>
+          </a:p>
+        </p:txBody>
+      </p:sp>
+      <p:sp>
+        <p:nvSpPr>
+          <p:cNvPr id="7" name="card-562"/>
+          <p:cNvSpPr/>
+          <p:nvPr/>
+        </p:nvSpPr>
+        <p:spPr>
+          <a:xfrm>
+            <a:off x="6199632" y="1280160"/>
+            <a:ext cx="5440680" cy="4892040"/>
+          </a:xfrm>
+          <a:prstGeom prst="roundRect">
+            <a:avLst>
+              <a:gd name="adj" fmla="val 1495"/>
+            </a:avLst>
+          </a:prstGeom>
+          <a:solidFill>
+            <a:srgbClr val="121214"/>
+          </a:solidFill>
+          <a:ln w="12700">
+            <a:solidFill>
+              <a:srgbClr val="2B2B31"/>
+            </a:solidFill>
+            <a:prstDash val="solid"/>
+          </a:ln>
+        </p:spPr>
+      </p:sp>
+      <p:sp>
+        <p:nvSpPr>
+          <p:cNvPr id="8" name="text-563"/>
           <p:cNvSpPr txBox="1"/>
           <p:nvPr/>
         </p:nvSpPr>
@@ -18683,7 +19530,7 @@
             <a:pPr algn="r"/>
             <a:fld id="{F7021451-1387-4CA6-816F-3879F97B5CBC}" type="slidenum">
               <a:rPr b="0" lang="en-US"/>
-              <a:t>21</a:t>
+              <a:t>22</a:t>
             </a:fld>
             <a:endParaRPr lang="en-US"/>
           </a:p>

</xml_diff>